<commit_message>
feat(ge-blogs): harden BeyondCorp/IAP live portal, add GitHub Actions CI, rebuild 7 slide decks & enforce cross-platform portability
</commit_message>
<xml_diff>
--- a/slides/ws1-google-slides-design-plugin-editable-slides.pptx
+++ b/slides/ws1-google-slides-design-plugin-editable-slides.pptx
@@ -2475,7 +2475,7 @@
                 <a:ea typeface="Google Sans" pitchFamily="34" charset="-122"/>
                 <a:cs typeface="Google Sans" pitchFamily="34" charset="-120"/>
               </a:rPr>
-              <a:t>Why It Matters (The SaaS AI Dilemma)</a:t>
+              <a:t>Why It Matters (SaaS AI Dilemma)</a:t>
             </a:r>
             <a:endParaRPr lang="en-US" sz="760" dirty="0"/>
           </a:p>
@@ -2508,7 +2508,7 @@
               <a:buNone/>
             </a:pPr>
             <a:r>
-              <a:rPr lang="en-US" sz="680" dirty="0">
+              <a:rPr lang="en-US" sz="710" dirty="0">
                 <a:solidFill>
                   <a:srgbClr val="5F6368"/>
                 </a:solidFill>
@@ -2516,9 +2516,9 @@
                 <a:ea typeface="Roboto" pitchFamily="34" charset="-122"/>
                 <a:cs typeface="Roboto" pitchFamily="34" charset="-120"/>
               </a:rPr>
-              <a:t>Dedicated projects per Standard tenant erode SaaS gross margins, whereas naive shared agents leak cross-tenant data via tool schemas and let one.</a:t>
-            </a:r>
-            <a:endParaRPr lang="en-US" sz="680" dirty="0"/>
+              <a:t>Dedicated projects erode SaaS gross margins, while naive shared agents leak tool schemas and allow quota starvation.</a:t>
+            </a:r>
+            <a:endParaRPr lang="en-US" sz="710" dirty="0"/>
           </a:p>
         </p:txBody>
       </p:sp>
@@ -2635,7 +2635,7 @@
               <a:buNone/>
             </a:pPr>
             <a:r>
-              <a:rPr lang="en-US" sz="680" dirty="0">
+              <a:rPr lang="en-US" sz="710" dirty="0">
                 <a:solidFill>
                   <a:srgbClr val="5F6368"/>
                 </a:solidFill>
@@ -2643,9 +2643,9 @@
                 <a:ea typeface="Roboto" pitchFamily="34" charset="-122"/>
                 <a:cs typeface="Roboto" pitchFamily="34" charset="-120"/>
               </a:rPr>
-              <a:t>ADK (OS syscall scheduler), MCP (POSIX tool driver ABI) &amp; ARD (chrooted VFS catalog) isolate every tenant turn across 5 cryptographic hops.</a:t>
-            </a:r>
-            <a:endParaRPr lang="en-US" sz="680" dirty="0"/>
+              <a:t>ADK (syscall scheduler), MCP (tool driver ABI) &amp; ARD (chrooted catalog) isolate every tenant across 5 hops.</a:t>
+            </a:r>
+            <a:endParaRPr lang="en-US" sz="710" dirty="0"/>
           </a:p>
         </p:txBody>
       </p:sp>
@@ -2729,7 +2729,7 @@
                 <a:ea typeface="Google Sans" pitchFamily="34" charset="-122"/>
                 <a:cs typeface="Google Sans" pitchFamily="34" charset="-120"/>
               </a:rPr>
-              <a:t>Three Topologies &amp; 80/20 Code Reuse</a:t>
+              <a:t>Three Topologies &amp; 80/20 Reuse</a:t>
             </a:r>
             <a:endParaRPr lang="en-US" sz="760" dirty="0"/>
           </a:p>
@@ -2762,7 +2762,7 @@
               <a:buNone/>
             </a:pPr>
             <a:r>
-              <a:rPr lang="en-US" sz="680" dirty="0">
+              <a:rPr lang="en-US" sz="710" dirty="0">
                 <a:solidFill>
                   <a:srgbClr val="5F6368"/>
                 </a:solidFill>
@@ -2770,9 +2770,9 @@
                 <a:ea typeface="Roboto" pitchFamily="34" charset="-122"/>
                 <a:cs typeface="Roboto" pitchFamily="34" charset="-120"/>
               </a:rPr>
-              <a:t>Pattern A (Pooled RLS + 90% prefix cache), Pattern B (Sovereign Silo VPC-SC + CMEK), and Pattern C (Dynamic Hybrid PSC + 0ms tier upgrade) share.</a:t>
-            </a:r>
-            <a:endParaRPr lang="en-US" sz="680" dirty="0"/>
+              <a:t>Pattern A (Pooled RLS), Pattern B (Sovereign Silos), and Pattern C (Hybrid PSC) share 80% identical Python ADK code.</a:t>
+            </a:r>
+            <a:endParaRPr lang="en-US" sz="710" dirty="0"/>
           </a:p>
         </p:txBody>
       </p:sp>
@@ -2856,7 +2856,7 @@
                 <a:ea typeface="Google Sans" pitchFamily="34" charset="-122"/>
                 <a:cs typeface="Google Sans" pitchFamily="34" charset="-120"/>
               </a:rPr>
-              <a:t>5-Hop Pipeline (~42ms p95 Overhead)</a:t>
+              <a:t>5-Hop Pipeline (~42ms p95 Gate)</a:t>
             </a:r>
             <a:endParaRPr lang="en-US" sz="760" dirty="0"/>
           </a:p>
@@ -2889,7 +2889,7 @@
               <a:buNone/>
             </a:pPr>
             <a:r>
-              <a:rPr lang="en-US" sz="680" dirty="0">
+              <a:rPr lang="en-US" sz="710" dirty="0">
                 <a:solidFill>
                   <a:srgbClr val="5F6368"/>
                 </a:solidFill>
@@ -2897,9 +2897,9 @@
                 <a:ea typeface="Roboto" pitchFamily="34" charset="-122"/>
                 <a:cs typeface="Roboto" pitchFamily="34" charset="-120"/>
               </a:rPr>
-              <a:t>Enforces KMS-signed STS JWTs (&lt;0.15ms cached JWKS verify), ARD pruning, targeted Valkey SCAN+UNLINK L1 eviction, streaming Model Armor/DLP.</a:t>
-            </a:r>
-            <a:endParaRPr lang="en-US" sz="680" dirty="0"/>
+              <a:t>Enforces KMS-signed OBO/DPoP tokens, ARD pruning, Valkey bulkheads, Model Armor DLP, and AlloyDB FORCE RLS.</a:t>
+            </a:r>
+            <a:endParaRPr lang="en-US" sz="710" dirty="0"/>
           </a:p>
         </p:txBody>
       </p:sp>
@@ -3853,7 +3853,7 @@
                 <a:ea typeface="Google Sans" pitchFamily="34" charset="-122"/>
                 <a:cs typeface="Google Sans" pitchFamily="34" charset="-120"/>
               </a:rPr>
-              <a:t>Verified Across 3 GCP Projects (#248990048888 • #638420508320 • #887605034827) • 12/12 Forensic PASS</a:t>
+              <a:t>Verified Across 3 GCP Projects (#248990048888 • #638420508320 • #887605034827) • 13/13 Forensic PASS</a:t>
             </a:r>
             <a:endParaRPr lang="en-US" sz="720" dirty="0"/>
           </a:p>
@@ -4586,7 +4586,7 @@
                 <a:ea typeface="Roboto" pitchFamily="34" charset="-122"/>
                 <a:cs typeface="Roboto" pitchFamily="34" charset="-120"/>
               </a:rPr>
-              <a:t>• CLI Gate: run_deep_forensic_audit.py (12/12 PASS)</a:t>
+              <a:t>• CLI Gate: run_deep_forensic_audit.py (13/13 PASS)</a:t>
             </a:r>
             <a:endParaRPr lang="en-US" sz="840" dirty="0"/>
           </a:p>
@@ -5667,7 +5667,7 @@
                 <a:ea typeface="Roboto" pitchFamily="34" charset="-122"/>
                 <a:cs typeface="Roboto" pitchFamily="34" charset="-120"/>
               </a:rPr>
-              <a:t>Certifies 20/20 GCP runtime suites plus 30/30 Inter-Cloud AWS AgentCore MCP target flows (60/60 assertions, 12/12 forensic gates).</a:t>
+              <a:t>Certifies 20/20 GCP runtime suites plus 30/30 Inter-Cloud AWS AgentCore MCP target flows (60/60 assertions, 13/13 forensic gates).</a:t>
             </a:r>
             <a:endParaRPr lang="en-US" sz="860" dirty="0"/>
           </a:p>
@@ -7931,7 +7931,7 @@
                 <a:ea typeface="Roboto" pitchFamily="34" charset="-122"/>
                 <a:cs typeface="Roboto" pitchFamily="34" charset="-120"/>
               </a:rPr>
-              <a:t>Enforce python3 -B scripts/run_deep_forensic_audit.py (12/12 PASS • 107/107 Assertions) across 20/20 GCP suites and 30/30 Inter-Cloud 10-SaaS MCP target assertions.</a:t>
+              <a:t>Enforce python3 -B scripts/run_deep_forensic_audit.py (13/13 PASS • 107/107 Assertions) across 20/20 GCP suites and 30/30 Inter-Cloud 10-SaaS MCP target assertions.</a:t>
             </a:r>
             <a:endParaRPr lang="en-US" sz="980" dirty="0"/>
           </a:p>
@@ -8032,7 +8032,7 @@
                 <a:ea typeface="Roboto" pitchFamily="34" charset="-122"/>
                 <a:cs typeface="Roboto" pitchFamily="34" charset="-120"/>
               </a:rPr>
-              <a:t>Target &amp; SLA: SLA: 12/12 Forensic (107/107) • 20/20 GCP + 30/30 10-SaaS MCP</a:t>
+              <a:t>Target &amp; SLA: SLA: 13/13 Forensic (107/107) • 20/20 GCP + 30/30 10-SaaS MCP</a:t>
             </a:r>
             <a:endParaRPr lang="en-US" sz="750" dirty="0"/>
           </a:p>
@@ -10537,7 +10537,7 @@
                           <a:ea typeface="Roboto" pitchFamily="34" charset="-122"/>
                           <a:cs typeface="Roboto" pitchFamily="34" charset="-120"/>
                         </a:rPr>
-                        <a:t>12/12 Forensic + 107/107 Runtime Assertions PASS • 84.7% Token &amp; 74% TCO Savings • &lt;30s HA RTO</a:t>
+                        <a:t>13/13 Forensic + 107/107 Runtime Assertions PASS • 84.7% Token &amp; 74% TCO Savings • &lt;30s HA RTO</a:t>
                       </a:r>
                       <a:endParaRPr lang="en-US" sz="870" dirty="0">
                         <a:latin typeface="Roboto" charset="0"/>
@@ -20555,11 +20555,11 @@
         <p:spPr>
           <a:xfrm>
             <a:off x="7443216" y="1700784"/>
-            <a:ext cx="4382719" cy="512064"/>
+            <a:ext cx="4382719" cy="594360"/>
           </a:xfrm>
           <a:prstGeom prst="roundRect">
             <a:avLst>
-              <a:gd name="adj" fmla="val 10714"/>
+              <a:gd name="adj" fmla="val 9231"/>
             </a:avLst>
           </a:prstGeom>
           <a:solidFill>
@@ -20582,7 +20582,7 @@
         <p:spPr>
           <a:xfrm>
             <a:off x="7443216" y="1700784"/>
-            <a:ext cx="64008" cy="512064"/>
+            <a:ext cx="64008" cy="594360"/>
           </a:xfrm>
           <a:prstGeom prst="rect">
             <a:avLst/>
@@ -20679,7 +20679,7 @@
               <a:buNone/>
             </a:pPr>
             <a:r>
-              <a:rPr lang="en-US" sz="740" b="1" dirty="0">
+              <a:rPr lang="en-US" sz="730" b="1" dirty="0">
                 <a:solidFill>
                   <a:srgbClr val="3C4043"/>
                 </a:solidFill>
@@ -20689,7 +20689,7 @@
               </a:rPr>
               <a:t>1. Routing Hub (Ingress &amp; Identity PEP)</a:t>
             </a:r>
-            <a:endParaRPr lang="en-US" sz="740" dirty="0"/>
+            <a:endParaRPr lang="en-US" sz="730" dirty="0"/>
           </a:p>
         </p:txBody>
       </p:sp>
@@ -20701,8 +20701,8 @@
         </p:nvSpPr>
         <p:spPr>
           <a:xfrm>
-            <a:off x="7552944" y="1920240"/>
-            <a:ext cx="4218127" cy="265176"/>
+            <a:off x="7552944" y="1901952"/>
+            <a:ext cx="4236415" cy="374904"/>
           </a:xfrm>
           <a:prstGeom prst="rect">
             <a:avLst/>
@@ -20718,7 +20718,7 @@
               <a:buNone/>
             </a:pPr>
             <a:r>
-              <a:rPr lang="en-US" sz="670" dirty="0">
+              <a:rPr lang="en-US" sz="660" dirty="0">
                 <a:solidFill>
                   <a:srgbClr val="5F6368"/>
                 </a:solidFill>
@@ -20728,7 +20728,7 @@
               </a:rPr>
               <a:t>Terminates TLS at External ALB, enforces Cloud Armor WAF &amp; Model Armor screening, authenticates via IAP, and resolves tenant tier.</a:t>
             </a:r>
-            <a:endParaRPr lang="en-US" sz="670" dirty="0"/>
+            <a:endParaRPr lang="en-US" sz="660" dirty="0"/>
           </a:p>
         </p:txBody>
       </p:sp>
@@ -20740,12 +20740,12 @@
         </p:nvSpPr>
         <p:spPr>
           <a:xfrm>
-            <a:off x="7443216" y="2267712"/>
-            <a:ext cx="4382719" cy="512064"/>
+            <a:off x="7443216" y="2340864"/>
+            <a:ext cx="4382719" cy="594360"/>
           </a:xfrm>
           <a:prstGeom prst="roundRect">
             <a:avLst>
-              <a:gd name="adj" fmla="val 10714"/>
+              <a:gd name="adj" fmla="val 9231"/>
             </a:avLst>
           </a:prstGeom>
           <a:solidFill>
@@ -20767,8 +20767,8 @@
         </p:nvSpPr>
         <p:spPr>
           <a:xfrm>
-            <a:off x="7443216" y="2267712"/>
-            <a:ext cx="64008" cy="512064"/>
+            <a:off x="7443216" y="2340864"/>
+            <a:ext cx="64008" cy="594360"/>
           </a:xfrm>
           <a:prstGeom prst="rect">
             <a:avLst/>
@@ -20787,7 +20787,7 @@
         </p:nvSpPr>
         <p:spPr>
           <a:xfrm>
-            <a:off x="7552944" y="2313432"/>
+            <a:off x="7552944" y="2386584"/>
             <a:ext cx="804672" cy="155448"/>
           </a:xfrm>
           <a:prstGeom prst="roundRect">
@@ -20809,7 +20809,7 @@
         </p:nvSpPr>
         <p:spPr>
           <a:xfrm>
-            <a:off x="7552944" y="2313432"/>
+            <a:off x="7552944" y="2386584"/>
             <a:ext cx="804672" cy="155448"/>
           </a:xfrm>
           <a:prstGeom prst="rect">
@@ -20848,7 +20848,7 @@
         </p:nvSpPr>
         <p:spPr>
           <a:xfrm>
-            <a:off x="8412480" y="2295144"/>
+            <a:off x="8412480" y="2368296"/>
             <a:ext cx="3358591" cy="182880"/>
           </a:xfrm>
           <a:prstGeom prst="rect">
@@ -20865,7 +20865,7 @@
               <a:buNone/>
             </a:pPr>
             <a:r>
-              <a:rPr lang="en-US" sz="740" b="1" dirty="0">
+              <a:rPr lang="en-US" sz="730" b="1" dirty="0">
                 <a:solidFill>
                   <a:srgbClr val="3C4043"/>
                 </a:solidFill>
@@ -20875,7 +20875,7 @@
               </a:rPr>
               <a:t>2. Central Governance &amp; Security Hub</a:t>
             </a:r>
-            <a:endParaRPr lang="en-US" sz="740" dirty="0"/>
+            <a:endParaRPr lang="en-US" sz="730" dirty="0"/>
           </a:p>
         </p:txBody>
       </p:sp>
@@ -20887,8 +20887,8 @@
         </p:nvSpPr>
         <p:spPr>
           <a:xfrm>
-            <a:off x="7552944" y="2487168"/>
-            <a:ext cx="4218127" cy="265176"/>
+            <a:off x="7552944" y="2542032"/>
+            <a:ext cx="4236415" cy="374904"/>
           </a:xfrm>
           <a:prstGeom prst="rect">
             <a:avLst/>
@@ -20904,7 +20904,7 @@
               <a:buNone/>
             </a:pPr>
             <a:r>
-              <a:rPr lang="en-US" sz="670" dirty="0">
+              <a:rPr lang="en-US" sz="660" dirty="0">
                 <a:solidFill>
                   <a:srgbClr val="5F6368"/>
                 </a:solidFill>
@@ -20914,7 +20914,7 @@
               </a:rPr>
               <a:t>Centralizes Security Command Center posture monitoring, IAM Principal Access Boundaries, Cloud KMS keys, and BigQuery OTel FinOps.</a:t>
             </a:r>
-            <a:endParaRPr lang="en-US" sz="670" dirty="0"/>
+            <a:endParaRPr lang="en-US" sz="660" dirty="0"/>
           </a:p>
         </p:txBody>
       </p:sp>
@@ -20926,12 +20926,12 @@
         </p:nvSpPr>
         <p:spPr>
           <a:xfrm>
-            <a:off x="7443216" y="2834640"/>
-            <a:ext cx="4382719" cy="512064"/>
+            <a:off x="7443216" y="2980944"/>
+            <a:ext cx="4382719" cy="594360"/>
           </a:xfrm>
           <a:prstGeom prst="roundRect">
             <a:avLst>
-              <a:gd name="adj" fmla="val 10714"/>
+              <a:gd name="adj" fmla="val 9231"/>
             </a:avLst>
           </a:prstGeom>
           <a:solidFill>
@@ -20953,8 +20953,8 @@
         </p:nvSpPr>
         <p:spPr>
           <a:xfrm>
-            <a:off x="7443216" y="2834640"/>
-            <a:ext cx="64008" cy="512064"/>
+            <a:off x="7443216" y="2980944"/>
+            <a:ext cx="64008" cy="594360"/>
           </a:xfrm>
           <a:prstGeom prst="rect">
             <a:avLst/>
@@ -20973,7 +20973,7 @@
         </p:nvSpPr>
         <p:spPr>
           <a:xfrm>
-            <a:off x="7552944" y="2880360"/>
+            <a:off x="7552944" y="3026664"/>
             <a:ext cx="804672" cy="155448"/>
           </a:xfrm>
           <a:prstGeom prst="roundRect">
@@ -20995,7 +20995,7 @@
         </p:nvSpPr>
         <p:spPr>
           <a:xfrm>
-            <a:off x="7552944" y="2880360"/>
+            <a:off x="7552944" y="3026664"/>
             <a:ext cx="804672" cy="155448"/>
           </a:xfrm>
           <a:prstGeom prst="rect">
@@ -21034,7 +21034,7 @@
         </p:nvSpPr>
         <p:spPr>
           <a:xfrm>
-            <a:off x="8412480" y="2862072"/>
+            <a:off x="8412480" y="3008376"/>
             <a:ext cx="3358591" cy="182880"/>
           </a:xfrm>
           <a:prstGeom prst="rect">
@@ -21051,7 +21051,7 @@
               <a:buNone/>
             </a:pPr>
             <a:r>
-              <a:rPr lang="en-US" sz="740" b="1" dirty="0">
+              <a:rPr lang="en-US" sz="730" b="1" dirty="0">
                 <a:solidFill>
                   <a:srgbClr val="3C4043"/>
                 </a:solidFill>
@@ -21061,7 +21061,7 @@
               </a:rPr>
               <a:t>3. Pattern A: Pooled Shared Runtime Spoke</a:t>
             </a:r>
-            <a:endParaRPr lang="en-US" sz="740" dirty="0"/>
+            <a:endParaRPr lang="en-US" sz="730" dirty="0"/>
           </a:p>
         </p:txBody>
       </p:sp>
@@ -21073,8 +21073,8 @@
         </p:nvSpPr>
         <p:spPr>
           <a:xfrm>
-            <a:off x="7552944" y="3054096"/>
-            <a:ext cx="4218127" cy="265176"/>
+            <a:off x="7552944" y="3182112"/>
+            <a:ext cx="4236415" cy="374904"/>
           </a:xfrm>
           <a:prstGeom prst="rect">
             <a:avLst/>
@@ -21090,7 +21090,7 @@
               <a:buNone/>
             </a:pPr>
             <a:r>
-              <a:rPr lang="en-US" sz="670" dirty="0">
+              <a:rPr lang="en-US" sz="660" dirty="0">
                 <a:solidFill>
                   <a:srgbClr val="5F6368"/>
                 </a:solidFill>
@@ -21100,7 +21100,7 @@
               </a:rPr>
               <a:t>Executes high-density multi-tenant workloads on shared Cloud Run / Agent Engine with 90% shared prompt caching and AlloyDB RLS.</a:t>
             </a:r>
-            <a:endParaRPr lang="en-US" sz="670" dirty="0"/>
+            <a:endParaRPr lang="en-US" sz="660" dirty="0"/>
           </a:p>
         </p:txBody>
       </p:sp>
@@ -21112,12 +21112,12 @@
         </p:nvSpPr>
         <p:spPr>
           <a:xfrm>
-            <a:off x="7443216" y="3401568"/>
-            <a:ext cx="4382719" cy="512064"/>
+            <a:off x="7443216" y="3621024"/>
+            <a:ext cx="4382719" cy="594360"/>
           </a:xfrm>
           <a:prstGeom prst="roundRect">
             <a:avLst>
-              <a:gd name="adj" fmla="val 10714"/>
+              <a:gd name="adj" fmla="val 9231"/>
             </a:avLst>
           </a:prstGeom>
           <a:solidFill>
@@ -21139,8 +21139,8 @@
         </p:nvSpPr>
         <p:spPr>
           <a:xfrm>
-            <a:off x="7443216" y="3401568"/>
-            <a:ext cx="64008" cy="512064"/>
+            <a:off x="7443216" y="3621024"/>
+            <a:ext cx="64008" cy="594360"/>
           </a:xfrm>
           <a:prstGeom prst="rect">
             <a:avLst/>
@@ -21159,7 +21159,7 @@
         </p:nvSpPr>
         <p:spPr>
           <a:xfrm>
-            <a:off x="7552944" y="3447288"/>
+            <a:off x="7552944" y="3666744"/>
             <a:ext cx="804672" cy="155448"/>
           </a:xfrm>
           <a:prstGeom prst="roundRect">
@@ -21181,7 +21181,7 @@
         </p:nvSpPr>
         <p:spPr>
           <a:xfrm>
-            <a:off x="7552944" y="3447288"/>
+            <a:off x="7552944" y="3666744"/>
             <a:ext cx="804672" cy="155448"/>
           </a:xfrm>
           <a:prstGeom prst="rect">
@@ -21220,7 +21220,7 @@
         </p:nvSpPr>
         <p:spPr>
           <a:xfrm>
-            <a:off x="8412480" y="3429000"/>
+            <a:off x="8412480" y="3648456"/>
             <a:ext cx="3358591" cy="182880"/>
           </a:xfrm>
           <a:prstGeom prst="rect">
@@ -21237,7 +21237,7 @@
               <a:buNone/>
             </a:pPr>
             <a:r>
-              <a:rPr lang="en-US" sz="740" b="1" dirty="0">
+              <a:rPr lang="en-US" sz="730" b="1" dirty="0">
                 <a:solidFill>
                   <a:srgbClr val="3C4043"/>
                 </a:solidFill>
@@ -21247,7 +21247,7 @@
               </a:rPr>
               <a:t>4. Pattern B Silos &amp; Pattern C PSC Spokes</a:t>
             </a:r>
-            <a:endParaRPr lang="en-US" sz="740" dirty="0"/>
+            <a:endParaRPr lang="en-US" sz="730" dirty="0"/>
           </a:p>
         </p:txBody>
       </p:sp>
@@ -21259,8 +21259,8 @@
         </p:nvSpPr>
         <p:spPr>
           <a:xfrm>
-            <a:off x="7552944" y="3621024"/>
-            <a:ext cx="4218127" cy="265176"/>
+            <a:off x="7552944" y="3822192"/>
+            <a:ext cx="4236415" cy="374904"/>
           </a:xfrm>
           <a:prstGeom prst="rect">
             <a:avLst/>
@@ -21276,7 +21276,7 @@
               <a:buNone/>
             </a:pPr>
             <a:r>
-              <a:rPr lang="en-US" sz="670" dirty="0">
+              <a:rPr lang="en-US" sz="625" dirty="0">
                 <a:solidFill>
                   <a:srgbClr val="5F6368"/>
                 </a:solidFill>
@@ -21286,7 +21286,7 @@
               </a:rPr>
               <a:t>Isolates regulated tenants inside dedicated VPC-SC projects with Cloud KMS CMEK kill-switches or unidirectional PSC service attachments.</a:t>
             </a:r>
-            <a:endParaRPr lang="en-US" sz="670" dirty="0"/>
+            <a:endParaRPr lang="en-US" sz="625" dirty="0"/>
           </a:p>
         </p:txBody>
       </p:sp>
@@ -21298,8 +21298,8 @@
         </p:nvSpPr>
         <p:spPr>
           <a:xfrm>
-            <a:off x="7461504" y="4005072"/>
-            <a:ext cx="4346143" cy="164592"/>
+            <a:off x="7461504" y="4288536"/>
+            <a:ext cx="4346143" cy="155448"/>
           </a:xfrm>
           <a:prstGeom prst="rect">
             <a:avLst/>
@@ -21315,7 +21315,7 @@
               <a:buNone/>
             </a:pPr>
             <a:r>
-              <a:rPr lang="en-US" sz="720" b="1" dirty="0">
+              <a:rPr lang="en-US" sz="710" b="1" dirty="0">
                 <a:solidFill>
                   <a:srgbClr val="5F6368"/>
                 </a:solidFill>
@@ -21325,7 +21325,7 @@
               </a:rPr>
               <a:t>KEY ARCHITECTURAL WALKTHROUGH POINTS</a:t>
             </a:r>
-            <a:endParaRPr lang="en-US" sz="720" dirty="0"/>
+            <a:endParaRPr lang="en-US" sz="710" dirty="0"/>
           </a:p>
         </p:txBody>
       </p:sp>
@@ -21337,12 +21337,12 @@
         </p:nvSpPr>
         <p:spPr>
           <a:xfrm>
-            <a:off x="7443216" y="4187952"/>
-            <a:ext cx="4382719" cy="428854"/>
+            <a:off x="7443216" y="4453128"/>
+            <a:ext cx="4382719" cy="378562"/>
           </a:xfrm>
           <a:prstGeom prst="roundRect">
             <a:avLst>
-              <a:gd name="adj" fmla="val 12793"/>
+              <a:gd name="adj" fmla="val 14493"/>
             </a:avLst>
           </a:prstGeom>
           <a:solidFill>
@@ -21364,7 +21364,7 @@
         </p:nvSpPr>
         <p:spPr>
           <a:xfrm>
-            <a:off x="7516368" y="4301338"/>
+            <a:off x="7516368" y="4541825"/>
             <a:ext cx="219456" cy="201168"/>
           </a:xfrm>
           <a:prstGeom prst="roundRect">
@@ -21386,7 +21386,7 @@
         </p:nvSpPr>
         <p:spPr>
           <a:xfrm>
-            <a:off x="7516368" y="4301338"/>
+            <a:off x="7516368" y="4541825"/>
             <a:ext cx="219456" cy="201168"/>
           </a:xfrm>
           <a:prstGeom prst="rect">
@@ -21425,8 +21425,8 @@
         </p:nvSpPr>
         <p:spPr>
           <a:xfrm>
-            <a:off x="7790688" y="4215384"/>
-            <a:ext cx="3980383" cy="373990"/>
+            <a:off x="7790688" y="4471416"/>
+            <a:ext cx="3980383" cy="341986"/>
           </a:xfrm>
           <a:prstGeom prst="rect">
             <a:avLst/>
@@ -21442,7 +21442,7 @@
               <a:buNone/>
             </a:pPr>
             <a:r>
-              <a:rPr lang="en-US" sz="690" dirty="0">
+              <a:rPr lang="en-US" sz="675" dirty="0">
                 <a:solidFill>
                   <a:srgbClr val="5F6368"/>
                 </a:solidFill>
@@ -21452,7 +21452,7 @@
               </a:rPr>
               <a:t>Blue Perimeter 1 (Routing Hub — Steps 1–3 / Hop 1): Global ALB, Cloud Armor header strip, and IAP OIDC/DPoP exchange (~8ms p95) mint the KMS-signed STS JWT and route by tenant tier.</a:t>
             </a:r>
-            <a:endParaRPr lang="en-US" sz="690" dirty="0"/>
+            <a:endParaRPr lang="en-US" sz="675" dirty="0"/>
           </a:p>
         </p:txBody>
       </p:sp>
@@ -21464,12 +21464,12 @@
         </p:nvSpPr>
         <p:spPr>
           <a:xfrm>
-            <a:off x="7443216" y="4667098"/>
-            <a:ext cx="4382719" cy="428854"/>
+            <a:off x="7443216" y="4872838"/>
+            <a:ext cx="4382719" cy="378562"/>
           </a:xfrm>
           <a:prstGeom prst="roundRect">
             <a:avLst>
-              <a:gd name="adj" fmla="val 12793"/>
+              <a:gd name="adj" fmla="val 14493"/>
             </a:avLst>
           </a:prstGeom>
           <a:solidFill>
@@ -21491,7 +21491,7 @@
         </p:nvSpPr>
         <p:spPr>
           <a:xfrm>
-            <a:off x="7516368" y="4780483"/>
+            <a:off x="7516368" y="4961534"/>
             <a:ext cx="219456" cy="201168"/>
           </a:xfrm>
           <a:prstGeom prst="roundRect">
@@ -21513,7 +21513,7 @@
         </p:nvSpPr>
         <p:spPr>
           <a:xfrm>
-            <a:off x="7516368" y="4780483"/>
+            <a:off x="7516368" y="4961534"/>
             <a:ext cx="219456" cy="201168"/>
           </a:xfrm>
           <a:prstGeom prst="rect">
@@ -21552,8 +21552,8 @@
         </p:nvSpPr>
         <p:spPr>
           <a:xfrm>
-            <a:off x="7790688" y="4694530"/>
-            <a:ext cx="3980383" cy="373990"/>
+            <a:off x="7790688" y="4891126"/>
+            <a:ext cx="3980383" cy="341986"/>
           </a:xfrm>
           <a:prstGeom prst="rect">
             <a:avLst/>
@@ -21569,7 +21569,7 @@
               <a:buNone/>
             </a:pPr>
             <a:r>
-              <a:rPr lang="en-US" sz="690" dirty="0">
+              <a:rPr lang="en-US" sz="675" dirty="0">
                 <a:solidFill>
                   <a:srgbClr val="5F6368"/>
                 </a:solidFill>
@@ -21579,7 +21579,7 @@
               </a:rPr>
               <a:t>Green Perimeter 2 (Governance Hub — Hops 2 &amp; 5): Discovery Engine ARD catalog filter (~4ms), Cloud KMS CMEK liveness, Security Command Center, and async BigQuery OTel FinOps (~5ms).</a:t>
             </a:r>
-            <a:endParaRPr lang="en-US" sz="690" dirty="0"/>
+            <a:endParaRPr lang="en-US" sz="675" dirty="0"/>
           </a:p>
         </p:txBody>
       </p:sp>
@@ -21591,12 +21591,12 @@
         </p:nvSpPr>
         <p:spPr>
           <a:xfrm>
-            <a:off x="7443216" y="5145329"/>
-            <a:ext cx="4382719" cy="428854"/>
+            <a:off x="7443216" y="5291633"/>
+            <a:ext cx="4382719" cy="378562"/>
           </a:xfrm>
           <a:prstGeom prst="roundRect">
             <a:avLst>
-              <a:gd name="adj" fmla="val 12793"/>
+              <a:gd name="adj" fmla="val 14493"/>
             </a:avLst>
           </a:prstGeom>
           <a:solidFill>
@@ -21618,7 +21618,7 @@
         </p:nvSpPr>
         <p:spPr>
           <a:xfrm>
-            <a:off x="7516368" y="5258714"/>
+            <a:off x="7516368" y="5380330"/>
             <a:ext cx="219456" cy="201168"/>
           </a:xfrm>
           <a:prstGeom prst="roundRect">
@@ -21640,7 +21640,7 @@
         </p:nvSpPr>
         <p:spPr>
           <a:xfrm>
-            <a:off x="7516368" y="5258714"/>
+            <a:off x="7516368" y="5380330"/>
             <a:ext cx="219456" cy="201168"/>
           </a:xfrm>
           <a:prstGeom prst="rect">
@@ -21679,8 +21679,8 @@
         </p:nvSpPr>
         <p:spPr>
           <a:xfrm>
-            <a:off x="7790688" y="5172761"/>
-            <a:ext cx="3980383" cy="373990"/>
+            <a:off x="7790688" y="5309921"/>
+            <a:ext cx="3980383" cy="341986"/>
           </a:xfrm>
           <a:prstGeom prst="rect">
             <a:avLst/>
@@ -21696,7 +21696,7 @@
               <a:buNone/>
             </a:pPr>
             <a:r>
-              <a:rPr lang="en-US" sz="690" dirty="0">
+              <a:rPr lang="en-US" sz="675" dirty="0">
                 <a:solidFill>
                   <a:srgbClr val="5F6368"/>
                 </a:solidFill>
@@ -21706,7 +21706,7 @@
               </a:rPr>
               <a:t>Yellow Perimeter 3 (Pattern A Pool — Steps 4–7 / Hops 3–5): gVisor (runsc) sandbox, Valkey RPM bulkheads (~3ms), Model Armor/DLP screening (Steps 4 &amp; 6, ~22ms), Gemini 2.5 Pro 90% cache (Step 5) &amp; AlloyDB RLS.</a:t>
             </a:r>
-            <a:endParaRPr lang="en-US" sz="690" dirty="0"/>
+            <a:endParaRPr lang="en-US" sz="675" dirty="0"/>
           </a:p>
         </p:txBody>
       </p:sp>
@@ -21718,12 +21718,12 @@
         </p:nvSpPr>
         <p:spPr>
           <a:xfrm>
-            <a:off x="7443216" y="5624474"/>
-            <a:ext cx="4382719" cy="428854"/>
+            <a:off x="7443216" y="5711342"/>
+            <a:ext cx="4382719" cy="378562"/>
           </a:xfrm>
           <a:prstGeom prst="roundRect">
             <a:avLst>
-              <a:gd name="adj" fmla="val 12793"/>
+              <a:gd name="adj" fmla="val 14493"/>
             </a:avLst>
           </a:prstGeom>
           <a:solidFill>
@@ -21745,7 +21745,7 @@
         </p:nvSpPr>
         <p:spPr>
           <a:xfrm>
-            <a:off x="7516368" y="5737860"/>
+            <a:off x="7516368" y="5800039"/>
             <a:ext cx="219456" cy="201168"/>
           </a:xfrm>
           <a:prstGeom prst="roundRect">
@@ -21767,7 +21767,7 @@
         </p:nvSpPr>
         <p:spPr>
           <a:xfrm>
-            <a:off x="7516368" y="5737860"/>
+            <a:off x="7516368" y="5800039"/>
             <a:ext cx="219456" cy="201168"/>
           </a:xfrm>
           <a:prstGeom prst="rect">
@@ -21806,8 +21806,8 @@
         </p:nvSpPr>
         <p:spPr>
           <a:xfrm>
-            <a:off x="7790688" y="5651906"/>
-            <a:ext cx="3980383" cy="373990"/>
+            <a:off x="7790688" y="5729630"/>
+            <a:ext cx="3980383" cy="341986"/>
           </a:xfrm>
           <a:prstGeom prst="rect">
             <a:avLst/>
@@ -21823,7 +21823,7 @@
               <a:buNone/>
             </a:pPr>
             <a:r>
-              <a:rPr lang="en-US" sz="690" dirty="0">
+              <a:rPr lang="en-US" sz="675" dirty="0">
                 <a:solidFill>
                   <a:srgbClr val="5F6368"/>
                 </a:solidFill>
@@ -21833,7 +21833,7 @@
               </a:rPr>
               <a:t>Red Perimeter 4 (Pattern B Silos &amp; Pattern C PSC Spokes): Per-tenant VPC-SC perimeters, IAM PAB, Managed Vertex Dedicated PT vs. Private GKE Gemma 3 27B GPUs, &lt;60s CMEK kill-switch &amp; /28 PSC NAT.</a:t>
             </a:r>
-            <a:endParaRPr lang="en-US" sz="690" dirty="0"/>
+            <a:endParaRPr lang="en-US" sz="675" dirty="0"/>
           </a:p>
         </p:txBody>
       </p:sp>
@@ -21845,7 +21845,7 @@
         </p:nvSpPr>
         <p:spPr>
           <a:xfrm>
-            <a:off x="7443216" y="6126480"/>
+            <a:off x="7443216" y="6144768"/>
             <a:ext cx="4382719" cy="329184"/>
           </a:xfrm>
           <a:prstGeom prst="roundRect">
@@ -21872,7 +21872,7 @@
         </p:nvSpPr>
         <p:spPr>
           <a:xfrm>
-            <a:off x="7498080" y="6126480"/>
+            <a:off x="7498080" y="6144768"/>
             <a:ext cx="4272991" cy="329184"/>
           </a:xfrm>
           <a:prstGeom prst="rect">
@@ -22638,7 +22638,7 @@
         </p:nvSpPr>
         <p:spPr>
           <a:xfrm flipH="1">
-            <a:off x="2948940" y="2475281"/>
+            <a:off x="2948940" y="2414016"/>
             <a:ext cx="148133" cy="0"/>
           </a:xfrm>
           <a:prstGeom prst="line">
@@ -22663,7 +22663,7 @@
         <p:spPr>
           <a:xfrm flipV="1">
             <a:off x="2948940" y="2306117"/>
-            <a:ext cx="0" cy="169164"/>
+            <a:ext cx="0" cy="107899"/>
           </a:xfrm>
           <a:prstGeom prst="line">
             <a:avLst/>
@@ -22709,7 +22709,7 @@
         </p:nvSpPr>
         <p:spPr>
           <a:xfrm flipH="1">
-            <a:off x="2948940" y="2475281"/>
+            <a:off x="2948940" y="2535631"/>
             <a:ext cx="148133" cy="0"/>
           </a:xfrm>
           <a:prstGeom prst="line">
@@ -22733,8 +22733,8 @@
         </p:nvSpPr>
         <p:spPr>
           <a:xfrm>
-            <a:off x="2948940" y="2475281"/>
-            <a:ext cx="0" cy="195682"/>
+            <a:off x="2948940" y="2535631"/>
+            <a:ext cx="0" cy="135331"/>
           </a:xfrm>
           <a:prstGeom prst="line">
             <a:avLst/>
@@ -30027,7 +30027,7 @@
         </p:nvSpPr>
         <p:spPr>
           <a:xfrm>
-            <a:off x="7406640" y="4498848"/>
+            <a:off x="7406640" y="4407408"/>
             <a:ext cx="292608" cy="292608"/>
           </a:xfrm>
           <a:prstGeom prst="rect">
@@ -30066,12 +30066,12 @@
         </p:nvSpPr>
         <p:spPr>
           <a:xfrm>
-            <a:off x="6272784" y="4517136"/>
-            <a:ext cx="859536" cy="274320"/>
+            <a:off x="6272784" y="4425696"/>
+            <a:ext cx="859536" cy="256032"/>
           </a:xfrm>
           <a:prstGeom prst="roundRect">
             <a:avLst>
-              <a:gd name="adj" fmla="val 16667"/>
+              <a:gd name="adj" fmla="val 17857"/>
             </a:avLst>
           </a:prstGeom>
           <a:solidFill>
@@ -30088,8 +30088,8 @@
         </p:nvSpPr>
         <p:spPr>
           <a:xfrm>
-            <a:off x="6272784" y="4517136"/>
-            <a:ext cx="859536" cy="274320"/>
+            <a:off x="6272784" y="4425696"/>
+            <a:ext cx="859536" cy="256032"/>
           </a:xfrm>
           <a:prstGeom prst="rect">
             <a:avLst/>
@@ -30105,7 +30105,7 @@
               <a:buNone/>
             </a:pPr>
             <a:r>
-              <a:rPr lang="en-US" sz="800" b="1" dirty="0">
+              <a:rPr lang="en-US" sz="780" b="1" dirty="0">
                 <a:solidFill>
                   <a:srgbClr val="FFFFFF"/>
                 </a:solidFill>
@@ -30115,7 +30115,7 @@
               </a:rPr>
               <a:t>RLS + 3LO</a:t>
             </a:r>
-            <a:endParaRPr lang="en-US" sz="800" dirty="0"/>
+            <a:endParaRPr lang="en-US" sz="780" dirty="0"/>
           </a:p>
         </p:txBody>
       </p:sp>
@@ -30127,8 +30127,8 @@
         </p:nvSpPr>
         <p:spPr>
           <a:xfrm>
-            <a:off x="5321808" y="4846320"/>
-            <a:ext cx="1847088" cy="438912"/>
+            <a:off x="5248656" y="4718304"/>
+            <a:ext cx="1938528" cy="411480"/>
           </a:xfrm>
           <a:prstGeom prst="rect">
             <a:avLst/>
@@ -30144,7 +30144,7 @@
               <a:buNone/>
             </a:pPr>
             <a:r>
-              <a:rPr lang="en-US" sz="800" b="1" dirty="0">
+              <a:rPr lang="en-US" sz="770" b="1" dirty="0">
                 <a:solidFill>
                   <a:srgbClr val="3C4043"/>
                 </a:solidFill>
@@ -30154,14 +30154,14 @@
               </a:rPr>
               <a:t>Hop 5 binds AlloyDB</a:t>
             </a:r>
-            <a:endParaRPr lang="en-US" sz="800" dirty="0"/>
+            <a:endParaRPr lang="en-US" sz="770" dirty="0"/>
           </a:p>
           <a:p>
             <a:pPr indent="0" marL="0">
               <a:buNone/>
             </a:pPr>
             <a:r>
-              <a:rPr lang="en-US" sz="800" b="1" dirty="0">
+              <a:rPr lang="en-US" sz="770" b="1" dirty="0">
                 <a:solidFill>
                   <a:srgbClr val="3C4043"/>
                 </a:solidFill>
@@ -30171,14 +30171,14 @@
               </a:rPr>
               <a:t>RLS &amp; vaults per-user</a:t>
             </a:r>
-            <a:endParaRPr lang="en-US" sz="800" dirty="0"/>
+            <a:endParaRPr lang="en-US" sz="770" dirty="0"/>
           </a:p>
           <a:p>
             <a:pPr indent="0" marL="0">
               <a:buNone/>
             </a:pPr>
             <a:r>
-              <a:rPr lang="en-US" sz="800" b="1" dirty="0">
+              <a:rPr lang="en-US" sz="770" b="1" dirty="0">
                 <a:solidFill>
                   <a:srgbClr val="3C4043"/>
                 </a:solidFill>
@@ -30188,7 +30188,7 @@
               </a:rPr>
               <a:t>3LO ({tenant}:{user})</a:t>
             </a:r>
-            <a:endParaRPr lang="en-US" sz="800" dirty="0"/>
+            <a:endParaRPr lang="en-US" sz="770" dirty="0"/>
           </a:p>
         </p:txBody>
       </p:sp>
@@ -30200,7 +30200,7 @@
         </p:nvSpPr>
         <p:spPr>
           <a:xfrm>
-            <a:off x="7342632" y="4901184"/>
+            <a:off x="7342632" y="4809744"/>
             <a:ext cx="2139696" cy="0"/>
           </a:xfrm>
           <a:prstGeom prst="line">
@@ -30224,7 +30224,7 @@
         </p:nvSpPr>
         <p:spPr>
           <a:xfrm>
-            <a:off x="7735824" y="4681728"/>
+            <a:off x="7735824" y="4590288"/>
             <a:ext cx="1682496" cy="182880"/>
           </a:xfrm>
           <a:prstGeom prst="rect">
@@ -30241,7 +30241,7 @@
               <a:buNone/>
             </a:pPr>
             <a:r>
-              <a:rPr lang="en-US" sz="800" b="1" dirty="0">
+              <a:rPr lang="en-US" sz="780" b="1" dirty="0">
                 <a:solidFill>
                   <a:srgbClr val="0F2942"/>
                 </a:solidFill>
@@ -30251,7 +30251,7 @@
               </a:rPr>
               <a:t>SET LOCAL tenant_id</a:t>
             </a:r>
-            <a:endParaRPr lang="en-US" sz="800" dirty="0"/>
+            <a:endParaRPr lang="en-US" sz="780" dirty="0"/>
           </a:p>
         </p:txBody>
       </p:sp>

</xml_diff>

<commit_message>
fix(slides): resolve WS2/WS5 micro-pill overlaps & Zone 3 connector mask across Google Slides
</commit_message>
<xml_diff>
--- a/slides/ws1-google-slides-design-plugin-editable-slides.pptx
+++ b/slides/ws1-google-slides-design-plugin-editable-slides.pptx
@@ -4923,7 +4923,7 @@
                 <a:ea typeface="Courier New" pitchFamily="34" charset="-122"/>
                 <a:cs typeface="Courier New" pitchFamily="34" charset="-120"/>
               </a:rPr>
-              <a:t>Source Module: scripts/verify_5_third_party_saas_products.py</a:t>
+              <a:t>Source Module: scripts/capture_genuine_3p_before_after_uis.mjs</a:t>
             </a:r>
             <a:endParaRPr lang="en-US" sz="720" dirty="0"/>
           </a:p>
@@ -22151,69 +22151,7 @@
       </p:sp>
       <p:sp>
         <p:nvSpPr>
-          <p:cNvPr id="75" name="Text 73"/>
-          <p:cNvSpPr/>
-          <p:nvPr/>
-        </p:nvSpPr>
-        <p:spPr>
-          <a:xfrm>
-            <a:off x="1560881" y="3970325"/>
-            <a:ext cx="1994306" cy="210312"/>
-          </a:xfrm>
-          <a:prstGeom prst="rect">
-            <a:avLst/>
-          </a:prstGeom>
-          <a:noFill/>
-          <a:ln/>
-        </p:spPr>
-        <p:txBody>
-          <a:bodyPr wrap="square" lIns="0" tIns="0" rIns="0" bIns="0" rtlCol="0" anchor="t"/>
-          <a:lstStyle/>
-          <a:p>
-            <a:pPr algn="l" indent="0" marL="0">
-              <a:lnSpc>
-                <a:spcPct val="102000"/>
-              </a:lnSpc>
-              <a:buNone/>
-            </a:pPr>
-            <a:r>
-              <a:rPr lang="en-US" sz="470" b="1" dirty="0">
-                <a:solidFill>
-                  <a:srgbClr val="202124"/>
-                </a:solidFill>
-                <a:latin typeface="Arial" pitchFamily="34" charset="0"/>
-                <a:ea typeface="Arial" pitchFamily="34" charset="-122"/>
-                <a:cs typeface="Arial" pitchFamily="34" charset="-120"/>
-              </a:rPr>
-              <a:t>Tenant Pool (Shared Runtime)</a:t>
-            </a:r>
-            <a:endParaRPr lang="en-US" sz="470" dirty="0"/>
-          </a:p>
-          <a:p>
-            <a:pPr algn="l" indent="0" marL="0">
-              <a:lnSpc>
-                <a:spcPct val="102000"/>
-              </a:lnSpc>
-              <a:buNone/>
-            </a:pPr>
-            <a:r>
-              <a:rPr lang="en-US" sz="400" dirty="0">
-                <a:solidFill>
-                  <a:srgbClr val="202124"/>
-                </a:solidFill>
-                <a:latin typeface="Arial" pitchFamily="34" charset="0"/>
-                <a:ea typeface="Arial" pitchFamily="34" charset="-122"/>
-                <a:cs typeface="Arial" pitchFamily="34" charset="-120"/>
-              </a:rPr>
-              <a:t>FinVault (8k Cap) &amp; RetailStream (4k Cap)</a:t>
-            </a:r>
-            <a:endParaRPr lang="en-US" sz="470" dirty="0"/>
-          </a:p>
-        </p:txBody>
-      </p:sp>
-      <p:sp>
-        <p:nvSpPr>
-          <p:cNvPr id="76" name="Shape 74"/>
+          <p:cNvPr id="75" name="Shape 73"/>
           <p:cNvSpPr/>
           <p:nvPr/>
         </p:nvSpPr>
@@ -22240,69 +22178,7 @@
       </p:sp>
       <p:sp>
         <p:nvSpPr>
-          <p:cNvPr id="77" name="Text 75"/>
-          <p:cNvSpPr/>
-          <p:nvPr/>
-        </p:nvSpPr>
-        <p:spPr>
-          <a:xfrm>
-            <a:off x="3925519" y="3970325"/>
-            <a:ext cx="1994306" cy="210312"/>
-          </a:xfrm>
-          <a:prstGeom prst="rect">
-            <a:avLst/>
-          </a:prstGeom>
-          <a:noFill/>
-          <a:ln/>
-        </p:spPr>
-        <p:txBody>
-          <a:bodyPr wrap="square" lIns="0" tIns="0" rIns="0" bIns="0" rtlCol="0" anchor="t"/>
-          <a:lstStyle/>
-          <a:p>
-            <a:pPr algn="l" indent="0" marL="0">
-              <a:lnSpc>
-                <a:spcPct val="102000"/>
-              </a:lnSpc>
-              <a:buNone/>
-            </a:pPr>
-            <a:r>
-              <a:rPr lang="en-US" sz="470" b="1" dirty="0">
-                <a:solidFill>
-                  <a:srgbClr val="202124"/>
-                </a:solidFill>
-                <a:latin typeface="Arial" pitchFamily="34" charset="0"/>
-                <a:ea typeface="Arial" pitchFamily="34" charset="-122"/>
-                <a:cs typeface="Arial" pitchFamily="34" charset="-120"/>
-              </a:rPr>
-              <a:t>Dedicated Sovereign Tenant Silo</a:t>
-            </a:r>
-            <a:endParaRPr lang="en-US" sz="470" dirty="0"/>
-          </a:p>
-          <a:p>
-            <a:pPr algn="l" indent="0" marL="0">
-              <a:lnSpc>
-                <a:spcPct val="102000"/>
-              </a:lnSpc>
-              <a:buNone/>
-            </a:pPr>
-            <a:r>
-              <a:rPr lang="en-US" sz="400" dirty="0">
-                <a:solidFill>
-                  <a:srgbClr val="202124"/>
-                </a:solidFill>
-                <a:latin typeface="Arial" pitchFamily="34" charset="0"/>
-                <a:ea typeface="Arial" pitchFamily="34" charset="-122"/>
-                <a:cs typeface="Arial" pitchFamily="34" charset="-120"/>
-              </a:rPr>
-              <a:t>VPC-SC + IAM PAB + finvault-silo-cmek + PSC</a:t>
-            </a:r>
-            <a:endParaRPr lang="en-US" sz="470" dirty="0"/>
-          </a:p>
-        </p:txBody>
-      </p:sp>
-      <p:sp>
-        <p:nvSpPr>
-          <p:cNvPr id="78" name="Shape 76"/>
+          <p:cNvPr id="76" name="Shape 74"/>
           <p:cNvSpPr/>
           <p:nvPr/>
         </p:nvSpPr>
@@ -22329,69 +22205,7 @@
       </p:sp>
       <p:sp>
         <p:nvSpPr>
-          <p:cNvPr id="79" name="Text 77"/>
-          <p:cNvSpPr/>
-          <p:nvPr/>
-        </p:nvSpPr>
-        <p:spPr>
-          <a:xfrm>
-            <a:off x="1482242" y="1926641"/>
-            <a:ext cx="1901952" cy="210312"/>
-          </a:xfrm>
-          <a:prstGeom prst="rect">
-            <a:avLst/>
-          </a:prstGeom>
-          <a:noFill/>
-          <a:ln/>
-        </p:spPr>
-        <p:txBody>
-          <a:bodyPr wrap="square" lIns="0" tIns="0" rIns="0" bIns="0" rtlCol="0" anchor="t"/>
-          <a:lstStyle/>
-          <a:p>
-            <a:pPr algn="l" indent="0" marL="0">
-              <a:lnSpc>
-                <a:spcPct val="102000"/>
-              </a:lnSpc>
-              <a:buNone/>
-            </a:pPr>
-            <a:r>
-              <a:rPr lang="en-US" sz="470" b="1" dirty="0">
-                <a:solidFill>
-                  <a:srgbClr val="202124"/>
-                </a:solidFill>
-                <a:latin typeface="Arial" pitchFamily="34" charset="0"/>
-                <a:ea typeface="Arial" pitchFamily="34" charset="-122"/>
-                <a:cs typeface="Arial" pitchFamily="34" charset="-120"/>
-              </a:rPr>
-              <a:t>Routing hub (Hop 1 &amp; Hop 2 PEP/PDP)</a:t>
-            </a:r>
-            <a:endParaRPr lang="en-US" sz="470" dirty="0"/>
-          </a:p>
-          <a:p>
-            <a:pPr algn="l" indent="0" marL="0">
-              <a:lnSpc>
-                <a:spcPct val="102000"/>
-              </a:lnSpc>
-              <a:buNone/>
-            </a:pPr>
-            <a:r>
-              <a:rPr lang="en-US" sz="400" dirty="0">
-                <a:solidFill>
-                  <a:srgbClr val="202124"/>
-                </a:solidFill>
-                <a:latin typeface="Arial" pitchFamily="34" charset="0"/>
-                <a:ea typeface="Arial" pitchFamily="34" charset="-122"/>
-                <a:cs typeface="Arial" pitchFamily="34" charset="-120"/>
-              </a:rPr>
-              <a:t>Central ingress, OBO+DPoP KMS Sign &amp; Discovery Engine Catalog filter</a:t>
-            </a:r>
-            <a:endParaRPr lang="en-US" sz="470" dirty="0"/>
-          </a:p>
-        </p:txBody>
-      </p:sp>
-      <p:sp>
-        <p:nvSpPr>
-          <p:cNvPr id="80" name="Shape 78"/>
+          <p:cNvPr id="77" name="Shape 75"/>
           <p:cNvSpPr/>
           <p:nvPr/>
         </p:nvSpPr>
@@ -22416,51 +22230,9 @@
           </a:ln>
         </p:spPr>
       </p:sp>
-      <p:sp>
-        <p:nvSpPr>
-          <p:cNvPr id="81" name="Text 79"/>
-          <p:cNvSpPr/>
-          <p:nvPr/>
-        </p:nvSpPr>
-        <p:spPr>
-          <a:xfrm>
-            <a:off x="4655210" y="1961388"/>
-            <a:ext cx="1315822" cy="210312"/>
-          </a:xfrm>
-          <a:prstGeom prst="rect">
-            <a:avLst/>
-          </a:prstGeom>
-          <a:noFill/>
-          <a:ln/>
-        </p:spPr>
-        <p:txBody>
-          <a:bodyPr wrap="square" lIns="0" tIns="0" rIns="0" bIns="0" rtlCol="0" anchor="t"/>
-          <a:lstStyle/>
-          <a:p>
-            <a:pPr algn="l" indent="0" marL="0">
-              <a:lnSpc>
-                <a:spcPct val="102000"/>
-              </a:lnSpc>
-              <a:buNone/>
-            </a:pPr>
-            <a:r>
-              <a:rPr lang="en-US" sz="430" b="1" dirty="0">
-                <a:solidFill>
-                  <a:srgbClr val="202124"/>
-                </a:solidFill>
-                <a:latin typeface="Arial" pitchFamily="34" charset="0"/>
-                <a:ea typeface="Arial" pitchFamily="34" charset="-122"/>
-                <a:cs typeface="Arial" pitchFamily="34" charset="-120"/>
-              </a:rPr>
-              <a:t>Central governance and FinOps observability hub</a:t>
-            </a:r>
-            <a:endParaRPr lang="en-US" sz="430" dirty="0"/>
-          </a:p>
-        </p:txBody>
-      </p:sp>
       <p:pic>
         <p:nvPicPr>
-          <p:cNvPr id="82" name="Image 0" descr="preencoded.png">    </p:cNvPr>
+          <p:cNvPr id="78" name="Image 0" descr="preencoded.png">    </p:cNvPr>
           <p:cNvPicPr>
             <a:picLocks noChangeAspect="1"/>
           </p:cNvPicPr>
@@ -22484,7 +22256,7 @@
       </p:pic>
       <p:sp>
         <p:nvSpPr>
-          <p:cNvPr id="83" name="Shape 80"/>
+          <p:cNvPr id="79" name="Shape 76"/>
           <p:cNvSpPr/>
           <p:nvPr/>
         </p:nvSpPr>
@@ -22508,7 +22280,7 @@
       </p:sp>
       <p:sp>
         <p:nvSpPr>
-          <p:cNvPr id="84" name="Shape 81"/>
+          <p:cNvPr id="80" name="Shape 77"/>
           <p:cNvSpPr/>
           <p:nvPr/>
         </p:nvSpPr>
@@ -22532,7 +22304,7 @@
       </p:sp>
       <p:sp>
         <p:nvSpPr>
-          <p:cNvPr id="85" name="Shape 82"/>
+          <p:cNvPr id="81" name="Shape 78"/>
           <p:cNvSpPr/>
           <p:nvPr/>
         </p:nvSpPr>
@@ -22556,7 +22328,7 @@
       </p:sp>
       <p:sp>
         <p:nvSpPr>
-          <p:cNvPr id="86" name="Shape 83"/>
+          <p:cNvPr id="82" name="Shape 79"/>
           <p:cNvSpPr/>
           <p:nvPr/>
         </p:nvSpPr>
@@ -22579,7 +22351,7 @@
       </p:sp>
       <p:sp>
         <p:nvSpPr>
-          <p:cNvPr id="87" name="Shape 84"/>
+          <p:cNvPr id="83" name="Shape 80"/>
           <p:cNvSpPr/>
           <p:nvPr/>
         </p:nvSpPr>
@@ -22603,7 +22375,7 @@
       </p:sp>
       <p:sp>
         <p:nvSpPr>
-          <p:cNvPr id="88" name="Shape 85"/>
+          <p:cNvPr id="84" name="Shape 81"/>
           <p:cNvSpPr/>
           <p:nvPr/>
         </p:nvSpPr>
@@ -22627,7 +22399,7 @@
       </p:sp>
       <p:sp>
         <p:nvSpPr>
-          <p:cNvPr id="89" name="Shape 86"/>
+          <p:cNvPr id="85" name="Shape 82"/>
           <p:cNvSpPr/>
           <p:nvPr/>
         </p:nvSpPr>
@@ -22650,7 +22422,7 @@
       </p:sp>
       <p:sp>
         <p:nvSpPr>
-          <p:cNvPr id="90" name="Shape 87"/>
+          <p:cNvPr id="86" name="Shape 83"/>
           <p:cNvSpPr/>
           <p:nvPr/>
         </p:nvSpPr>
@@ -22674,7 +22446,7 @@
       </p:sp>
       <p:sp>
         <p:nvSpPr>
-          <p:cNvPr id="91" name="Shape 88"/>
+          <p:cNvPr id="87" name="Shape 84"/>
           <p:cNvSpPr/>
           <p:nvPr/>
         </p:nvSpPr>
@@ -22699,7 +22471,7 @@
       </p:sp>
       <p:sp>
         <p:nvSpPr>
-          <p:cNvPr id="92" name="Shape 89"/>
+          <p:cNvPr id="88" name="Shape 85"/>
           <p:cNvSpPr/>
           <p:nvPr/>
         </p:nvSpPr>
@@ -22723,7 +22495,7 @@
       </p:sp>
       <p:sp>
         <p:nvSpPr>
-          <p:cNvPr id="93" name="Shape 90"/>
+          <p:cNvPr id="89" name="Shape 86"/>
           <p:cNvSpPr/>
           <p:nvPr/>
         </p:nvSpPr>
@@ -22747,7 +22519,7 @@
       </p:sp>
       <p:sp>
         <p:nvSpPr>
-          <p:cNvPr id="94" name="Shape 91"/>
+          <p:cNvPr id="90" name="Shape 87"/>
           <p:cNvSpPr/>
           <p:nvPr/>
         </p:nvSpPr>
@@ -22770,7 +22542,7 @@
       </p:sp>
       <p:sp>
         <p:nvSpPr>
-          <p:cNvPr id="95" name="Shape 92"/>
+          <p:cNvPr id="91" name="Shape 88"/>
           <p:cNvSpPr/>
           <p:nvPr/>
         </p:nvSpPr>
@@ -22793,7 +22565,7 @@
       </p:sp>
       <p:sp>
         <p:nvSpPr>
-          <p:cNvPr id="96" name="Shape 93"/>
+          <p:cNvPr id="92" name="Shape 89"/>
           <p:cNvSpPr/>
           <p:nvPr/>
         </p:nvSpPr>
@@ -22817,7 +22589,7 @@
       </p:sp>
       <p:sp>
         <p:nvSpPr>
-          <p:cNvPr id="97" name="Shape 94"/>
+          <p:cNvPr id="93" name="Shape 90"/>
           <p:cNvSpPr/>
           <p:nvPr/>
         </p:nvSpPr>
@@ -22841,7 +22613,7 @@
       </p:sp>
       <p:sp>
         <p:nvSpPr>
-          <p:cNvPr id="98" name="Shape 95"/>
+          <p:cNvPr id="94" name="Shape 91"/>
           <p:cNvSpPr/>
           <p:nvPr/>
         </p:nvSpPr>
@@ -22864,7 +22636,7 @@
       </p:sp>
       <p:sp>
         <p:nvSpPr>
-          <p:cNvPr id="99" name="Shape 96"/>
+          <p:cNvPr id="95" name="Shape 92"/>
           <p:cNvSpPr/>
           <p:nvPr/>
         </p:nvSpPr>
@@ -22888,7 +22660,7 @@
       </p:sp>
       <p:sp>
         <p:nvSpPr>
-          <p:cNvPr id="100" name="Shape 97"/>
+          <p:cNvPr id="96" name="Shape 93"/>
           <p:cNvSpPr/>
           <p:nvPr/>
         </p:nvSpPr>
@@ -22912,7 +22684,7 @@
       </p:sp>
       <p:sp>
         <p:nvSpPr>
-          <p:cNvPr id="101" name="Shape 98"/>
+          <p:cNvPr id="97" name="Shape 94"/>
           <p:cNvSpPr/>
           <p:nvPr/>
         </p:nvSpPr>
@@ -22935,7 +22707,7 @@
       </p:sp>
       <p:sp>
         <p:nvSpPr>
-          <p:cNvPr id="102" name="Shape 99"/>
+          <p:cNvPr id="98" name="Shape 95"/>
           <p:cNvSpPr/>
           <p:nvPr/>
         </p:nvSpPr>
@@ -22959,7 +22731,7 @@
       </p:sp>
       <p:sp>
         <p:nvSpPr>
-          <p:cNvPr id="103" name="Shape 100"/>
+          <p:cNvPr id="99" name="Shape 96"/>
           <p:cNvSpPr/>
           <p:nvPr/>
         </p:nvSpPr>
@@ -22982,7 +22754,7 @@
       </p:sp>
       <p:sp>
         <p:nvSpPr>
-          <p:cNvPr id="104" name="Shape 101"/>
+          <p:cNvPr id="100" name="Shape 97"/>
           <p:cNvSpPr/>
           <p:nvPr/>
         </p:nvSpPr>
@@ -23005,7 +22777,7 @@
       </p:sp>
       <p:sp>
         <p:nvSpPr>
-          <p:cNvPr id="105" name="Shape 102"/>
+          <p:cNvPr id="101" name="Shape 98"/>
           <p:cNvSpPr/>
           <p:nvPr/>
         </p:nvSpPr>
@@ -23029,7 +22801,7 @@
       </p:sp>
       <p:sp>
         <p:nvSpPr>
-          <p:cNvPr id="106" name="Shape 103"/>
+          <p:cNvPr id="102" name="Shape 99"/>
           <p:cNvSpPr/>
           <p:nvPr/>
         </p:nvSpPr>
@@ -23053,7 +22825,7 @@
       </p:sp>
       <p:sp>
         <p:nvSpPr>
-          <p:cNvPr id="107" name="Shape 104"/>
+          <p:cNvPr id="103" name="Shape 100"/>
           <p:cNvSpPr/>
           <p:nvPr/>
         </p:nvSpPr>
@@ -23076,7 +22848,7 @@
       </p:sp>
       <p:sp>
         <p:nvSpPr>
-          <p:cNvPr id="108" name="Shape 105"/>
+          <p:cNvPr id="104" name="Shape 101"/>
           <p:cNvSpPr/>
           <p:nvPr/>
         </p:nvSpPr>
@@ -23100,7 +22872,7 @@
       </p:sp>
       <p:sp>
         <p:nvSpPr>
-          <p:cNvPr id="109" name="Shape 106"/>
+          <p:cNvPr id="105" name="Shape 102"/>
           <p:cNvSpPr/>
           <p:nvPr/>
         </p:nvSpPr>
@@ -23124,7 +22896,7 @@
       </p:sp>
       <p:sp>
         <p:nvSpPr>
-          <p:cNvPr id="110" name="Shape 107"/>
+          <p:cNvPr id="106" name="Shape 103"/>
           <p:cNvSpPr/>
           <p:nvPr/>
         </p:nvSpPr>
@@ -23147,7 +22919,7 @@
       </p:sp>
       <p:sp>
         <p:nvSpPr>
-          <p:cNvPr id="111" name="Shape 108"/>
+          <p:cNvPr id="107" name="Shape 104"/>
           <p:cNvSpPr/>
           <p:nvPr/>
         </p:nvSpPr>
@@ -23171,7 +22943,7 @@
       </p:sp>
       <p:sp>
         <p:nvSpPr>
-          <p:cNvPr id="112" name="Shape 109"/>
+          <p:cNvPr id="108" name="Shape 105"/>
           <p:cNvSpPr/>
           <p:nvPr/>
         </p:nvSpPr>
@@ -23195,7 +22967,7 @@
       </p:sp>
       <p:sp>
         <p:nvSpPr>
-          <p:cNvPr id="113" name="Shape 110"/>
+          <p:cNvPr id="109" name="Shape 106"/>
           <p:cNvSpPr/>
           <p:nvPr/>
         </p:nvSpPr>
@@ -23219,7 +22991,7 @@
       </p:sp>
       <p:sp>
         <p:nvSpPr>
-          <p:cNvPr id="114" name="Shape 111"/>
+          <p:cNvPr id="110" name="Shape 107"/>
           <p:cNvSpPr/>
           <p:nvPr/>
         </p:nvSpPr>
@@ -23243,7 +23015,7 @@
       </p:sp>
       <p:sp>
         <p:nvSpPr>
-          <p:cNvPr id="115" name="Shape 112"/>
+          <p:cNvPr id="111" name="Shape 108"/>
           <p:cNvSpPr/>
           <p:nvPr/>
         </p:nvSpPr>
@@ -23267,7 +23039,7 @@
       </p:sp>
       <p:sp>
         <p:nvSpPr>
-          <p:cNvPr id="116" name="Shape 113"/>
+          <p:cNvPr id="112" name="Shape 109"/>
           <p:cNvSpPr/>
           <p:nvPr/>
         </p:nvSpPr>
@@ -23291,7 +23063,7 @@
       </p:sp>
       <p:sp>
         <p:nvSpPr>
-          <p:cNvPr id="117" name="Shape 114"/>
+          <p:cNvPr id="113" name="Shape 110"/>
           <p:cNvSpPr/>
           <p:nvPr/>
         </p:nvSpPr>
@@ -23314,7 +23086,7 @@
       </p:sp>
       <p:sp>
         <p:nvSpPr>
-          <p:cNvPr id="118" name="Shape 115"/>
+          <p:cNvPr id="114" name="Shape 111"/>
           <p:cNvSpPr/>
           <p:nvPr/>
         </p:nvSpPr>
@@ -23338,7 +23110,7 @@
       </p:sp>
       <p:sp>
         <p:nvSpPr>
-          <p:cNvPr id="119" name="Shape 116"/>
+          <p:cNvPr id="115" name="Shape 112"/>
           <p:cNvSpPr/>
           <p:nvPr/>
         </p:nvSpPr>
@@ -23362,7 +23134,7 @@
       </p:sp>
       <p:sp>
         <p:nvSpPr>
-          <p:cNvPr id="120" name="Shape 117"/>
+          <p:cNvPr id="116" name="Shape 113"/>
           <p:cNvSpPr/>
           <p:nvPr/>
         </p:nvSpPr>
@@ -23385,7 +23157,7 @@
       </p:sp>
       <p:sp>
         <p:nvSpPr>
-          <p:cNvPr id="121" name="Shape 118"/>
+          <p:cNvPr id="117" name="Shape 114"/>
           <p:cNvSpPr/>
           <p:nvPr/>
         </p:nvSpPr>
@@ -23409,7 +23181,7 @@
       </p:sp>
       <p:sp>
         <p:nvSpPr>
-          <p:cNvPr id="122" name="Shape 119"/>
+          <p:cNvPr id="118" name="Shape 115"/>
           <p:cNvSpPr/>
           <p:nvPr/>
         </p:nvSpPr>
@@ -23433,7 +23205,7 @@
       </p:sp>
       <p:sp>
         <p:nvSpPr>
-          <p:cNvPr id="123" name="Shape 120"/>
+          <p:cNvPr id="119" name="Shape 116"/>
           <p:cNvSpPr/>
           <p:nvPr/>
         </p:nvSpPr>
@@ -23457,7 +23229,7 @@
       </p:sp>
       <p:sp>
         <p:nvSpPr>
-          <p:cNvPr id="124" name="Shape 121"/>
+          <p:cNvPr id="120" name="Shape 117"/>
           <p:cNvSpPr/>
           <p:nvPr/>
         </p:nvSpPr>
@@ -23481,7 +23253,7 @@
       </p:sp>
       <p:sp>
         <p:nvSpPr>
-          <p:cNvPr id="125" name="Shape 122"/>
+          <p:cNvPr id="121" name="Shape 118"/>
           <p:cNvSpPr/>
           <p:nvPr/>
         </p:nvSpPr>
@@ -23505,13 +23277,13 @@
       </p:sp>
       <p:sp>
         <p:nvSpPr>
-          <p:cNvPr id="126" name="Shape 123"/>
-          <p:cNvSpPr/>
-          <p:nvPr/>
-        </p:nvSpPr>
-        <p:spPr>
-          <a:xfrm>
-            <a:off x="1473098" y="3802075"/>
+          <p:cNvPr id="122" name="Shape 119"/>
+          <p:cNvSpPr/>
+          <p:nvPr/>
+        </p:nvSpPr>
+        <p:spPr>
+          <a:xfrm>
+            <a:off x="1477670" y="3802075"/>
             <a:ext cx="1926641" cy="113386"/>
           </a:xfrm>
           <a:prstGeom prst="rect">
@@ -23525,7 +23297,7 @@
       </p:sp>
       <p:sp>
         <p:nvSpPr>
-          <p:cNvPr id="127" name="Text 124"/>
+          <p:cNvPr id="123" name="Text 120"/>
           <p:cNvSpPr/>
           <p:nvPr/>
         </p:nvSpPr>
@@ -23567,13 +23339,13 @@
       </p:sp>
       <p:sp>
         <p:nvSpPr>
-          <p:cNvPr id="128" name="Shape 125"/>
-          <p:cNvSpPr/>
-          <p:nvPr/>
-        </p:nvSpPr>
-        <p:spPr>
-          <a:xfrm>
-            <a:off x="3837737" y="3802075"/>
+          <p:cNvPr id="124" name="Shape 121"/>
+          <p:cNvSpPr/>
+          <p:nvPr/>
+        </p:nvSpPr>
+        <p:spPr>
+          <a:xfrm>
+            <a:off x="3842309" y="3802075"/>
             <a:ext cx="1636776" cy="113386"/>
           </a:xfrm>
           <a:prstGeom prst="rect">
@@ -23587,7 +23359,7 @@
       </p:sp>
       <p:sp>
         <p:nvSpPr>
-          <p:cNvPr id="129" name="Text 126"/>
+          <p:cNvPr id="125" name="Text 122"/>
           <p:cNvSpPr/>
           <p:nvPr/>
         </p:nvSpPr>
@@ -23629,7 +23401,315 @@
       </p:sp>
       <p:sp>
         <p:nvSpPr>
+          <p:cNvPr id="126" name="Shape 123"/>
+          <p:cNvSpPr/>
+          <p:nvPr/>
+        </p:nvSpPr>
+        <p:spPr>
+          <a:xfrm>
+            <a:off x="1547165" y="3964838"/>
+            <a:ext cx="1239926" cy="196596"/>
+          </a:xfrm>
+          <a:prstGeom prst="rect">
+            <a:avLst/>
+          </a:prstGeom>
+          <a:solidFill>
+            <a:srgbClr val="FEEFC3"/>
+          </a:solidFill>
+          <a:ln/>
+        </p:spPr>
+      </p:sp>
+      <p:sp>
+        <p:nvSpPr>
+          <p:cNvPr id="127" name="Text 124"/>
+          <p:cNvSpPr/>
+          <p:nvPr/>
+        </p:nvSpPr>
+        <p:spPr>
+          <a:xfrm>
+            <a:off x="1560881" y="3970325"/>
+            <a:ext cx="1994306" cy="210312"/>
+          </a:xfrm>
+          <a:prstGeom prst="rect">
+            <a:avLst/>
+          </a:prstGeom>
+          <a:noFill/>
+          <a:ln/>
+        </p:spPr>
+        <p:txBody>
+          <a:bodyPr wrap="square" lIns="0" tIns="0" rIns="0" bIns="0" rtlCol="0" anchor="t"/>
+          <a:lstStyle/>
+          <a:p>
+            <a:pPr algn="l" indent="0" marL="0">
+              <a:lnSpc>
+                <a:spcPct val="102000"/>
+              </a:lnSpc>
+              <a:buNone/>
+            </a:pPr>
+            <a:r>
+              <a:rPr lang="en-US" sz="470" b="1" dirty="0">
+                <a:solidFill>
+                  <a:srgbClr val="202124"/>
+                </a:solidFill>
+                <a:latin typeface="Arial" pitchFamily="34" charset="0"/>
+                <a:ea typeface="Arial" pitchFamily="34" charset="-122"/>
+                <a:cs typeface="Arial" pitchFamily="34" charset="-120"/>
+              </a:rPr>
+              <a:t>Tenant Pool (Shared Runtime)</a:t>
+            </a:r>
+            <a:endParaRPr lang="en-US" sz="470" dirty="0"/>
+          </a:p>
+          <a:p>
+            <a:pPr algn="l" indent="0" marL="0">
+              <a:lnSpc>
+                <a:spcPct val="102000"/>
+              </a:lnSpc>
+              <a:buNone/>
+            </a:pPr>
+            <a:r>
+              <a:rPr lang="en-US" sz="400" dirty="0">
+                <a:solidFill>
+                  <a:srgbClr val="202124"/>
+                </a:solidFill>
+                <a:latin typeface="Arial" pitchFamily="34" charset="0"/>
+                <a:ea typeface="Arial" pitchFamily="34" charset="-122"/>
+                <a:cs typeface="Arial" pitchFamily="34" charset="-120"/>
+              </a:rPr>
+              <a:t>FinVault (8k Cap) &amp; RetailStream (4k Cap)</a:t>
+            </a:r>
+            <a:endParaRPr lang="en-US" sz="470" dirty="0"/>
+          </a:p>
+        </p:txBody>
+      </p:sp>
+      <p:sp>
+        <p:nvSpPr>
+          <p:cNvPr id="128" name="Shape 125"/>
+          <p:cNvSpPr/>
+          <p:nvPr/>
+        </p:nvSpPr>
+        <p:spPr>
+          <a:xfrm>
+            <a:off x="3911803" y="3964838"/>
+            <a:ext cx="1296619" cy="196596"/>
+          </a:xfrm>
+          <a:prstGeom prst="rect">
+            <a:avLst/>
+          </a:prstGeom>
+          <a:solidFill>
+            <a:srgbClr val="FAD2CF"/>
+          </a:solidFill>
+          <a:ln/>
+        </p:spPr>
+      </p:sp>
+      <p:sp>
+        <p:nvSpPr>
+          <p:cNvPr id="129" name="Text 126"/>
+          <p:cNvSpPr/>
+          <p:nvPr/>
+        </p:nvSpPr>
+        <p:spPr>
+          <a:xfrm>
+            <a:off x="3925519" y="3970325"/>
+            <a:ext cx="1994306" cy="210312"/>
+          </a:xfrm>
+          <a:prstGeom prst="rect">
+            <a:avLst/>
+          </a:prstGeom>
+          <a:noFill/>
+          <a:ln/>
+        </p:spPr>
+        <p:txBody>
+          <a:bodyPr wrap="square" lIns="0" tIns="0" rIns="0" bIns="0" rtlCol="0" anchor="t"/>
+          <a:lstStyle/>
+          <a:p>
+            <a:pPr algn="l" indent="0" marL="0">
+              <a:lnSpc>
+                <a:spcPct val="102000"/>
+              </a:lnSpc>
+              <a:buNone/>
+            </a:pPr>
+            <a:r>
+              <a:rPr lang="en-US" sz="470" b="1" dirty="0">
+                <a:solidFill>
+                  <a:srgbClr val="202124"/>
+                </a:solidFill>
+                <a:latin typeface="Arial" pitchFamily="34" charset="0"/>
+                <a:ea typeface="Arial" pitchFamily="34" charset="-122"/>
+                <a:cs typeface="Arial" pitchFamily="34" charset="-120"/>
+              </a:rPr>
+              <a:t>Dedicated Sovereign Tenant Silo</a:t>
+            </a:r>
+            <a:endParaRPr lang="en-US" sz="470" dirty="0"/>
+          </a:p>
+          <a:p>
+            <a:pPr algn="l" indent="0" marL="0">
+              <a:lnSpc>
+                <a:spcPct val="102000"/>
+              </a:lnSpc>
+              <a:buNone/>
+            </a:pPr>
+            <a:r>
+              <a:rPr lang="en-US" sz="400" dirty="0">
+                <a:solidFill>
+                  <a:srgbClr val="202124"/>
+                </a:solidFill>
+                <a:latin typeface="Arial" pitchFamily="34" charset="0"/>
+                <a:ea typeface="Arial" pitchFamily="34" charset="-122"/>
+                <a:cs typeface="Arial" pitchFamily="34" charset="-120"/>
+              </a:rPr>
+              <a:t>VPC-SC + IAM PAB + finvault-silo-cmek + PSC</a:t>
+            </a:r>
+            <a:endParaRPr lang="en-US" sz="470" dirty="0"/>
+          </a:p>
+        </p:txBody>
+      </p:sp>
+      <p:sp>
+        <p:nvSpPr>
           <p:cNvPr id="130" name="Shape 127"/>
+          <p:cNvSpPr/>
+          <p:nvPr/>
+        </p:nvSpPr>
+        <p:spPr>
+          <a:xfrm>
+            <a:off x="1468526" y="1921154"/>
+            <a:ext cx="1901952" cy="196596"/>
+          </a:xfrm>
+          <a:prstGeom prst="rect">
+            <a:avLst/>
+          </a:prstGeom>
+          <a:solidFill>
+            <a:srgbClr val="AECBFA"/>
+          </a:solidFill>
+          <a:ln/>
+        </p:spPr>
+      </p:sp>
+      <p:sp>
+        <p:nvSpPr>
+          <p:cNvPr id="131" name="Text 128"/>
+          <p:cNvSpPr/>
+          <p:nvPr/>
+        </p:nvSpPr>
+        <p:spPr>
+          <a:xfrm>
+            <a:off x="1482242" y="1926641"/>
+            <a:ext cx="1901952" cy="210312"/>
+          </a:xfrm>
+          <a:prstGeom prst="rect">
+            <a:avLst/>
+          </a:prstGeom>
+          <a:noFill/>
+          <a:ln/>
+        </p:spPr>
+        <p:txBody>
+          <a:bodyPr wrap="square" lIns="0" tIns="0" rIns="0" bIns="0" rtlCol="0" anchor="t"/>
+          <a:lstStyle/>
+          <a:p>
+            <a:pPr algn="l" indent="0" marL="0">
+              <a:lnSpc>
+                <a:spcPct val="102000"/>
+              </a:lnSpc>
+              <a:buNone/>
+            </a:pPr>
+            <a:r>
+              <a:rPr lang="en-US" sz="470" b="1" dirty="0">
+                <a:solidFill>
+                  <a:srgbClr val="202124"/>
+                </a:solidFill>
+                <a:latin typeface="Arial" pitchFamily="34" charset="0"/>
+                <a:ea typeface="Arial" pitchFamily="34" charset="-122"/>
+                <a:cs typeface="Arial" pitchFamily="34" charset="-120"/>
+              </a:rPr>
+              <a:t>Routing hub (Hop 1 &amp; Hop 2 PEP/PDP)</a:t>
+            </a:r>
+            <a:endParaRPr lang="en-US" sz="470" dirty="0"/>
+          </a:p>
+          <a:p>
+            <a:pPr algn="l" indent="0" marL="0">
+              <a:lnSpc>
+                <a:spcPct val="102000"/>
+              </a:lnSpc>
+              <a:buNone/>
+            </a:pPr>
+            <a:r>
+              <a:rPr lang="en-US" sz="400" dirty="0">
+                <a:solidFill>
+                  <a:srgbClr val="202124"/>
+                </a:solidFill>
+                <a:latin typeface="Arial" pitchFamily="34" charset="0"/>
+                <a:ea typeface="Arial" pitchFamily="34" charset="-122"/>
+                <a:cs typeface="Arial" pitchFamily="34" charset="-120"/>
+              </a:rPr>
+              <a:t>Central ingress, OBO+DPoP KMS Sign &amp; Discovery Engine Catalog filter</a:t>
+            </a:r>
+            <a:endParaRPr lang="en-US" sz="470" dirty="0"/>
+          </a:p>
+        </p:txBody>
+      </p:sp>
+      <p:sp>
+        <p:nvSpPr>
+          <p:cNvPr id="132" name="Shape 129"/>
+          <p:cNvSpPr/>
+          <p:nvPr/>
+        </p:nvSpPr>
+        <p:spPr>
+          <a:xfrm>
+            <a:off x="4641494" y="1955902"/>
+            <a:ext cx="1315822" cy="118872"/>
+          </a:xfrm>
+          <a:prstGeom prst="rect">
+            <a:avLst/>
+          </a:prstGeom>
+          <a:solidFill>
+            <a:srgbClr val="CEEAD6"/>
+          </a:solidFill>
+          <a:ln/>
+        </p:spPr>
+      </p:sp>
+      <p:sp>
+        <p:nvSpPr>
+          <p:cNvPr id="133" name="Text 130"/>
+          <p:cNvSpPr/>
+          <p:nvPr/>
+        </p:nvSpPr>
+        <p:spPr>
+          <a:xfrm>
+            <a:off x="4655210" y="1961388"/>
+            <a:ext cx="1315822" cy="210312"/>
+          </a:xfrm>
+          <a:prstGeom prst="rect">
+            <a:avLst/>
+          </a:prstGeom>
+          <a:noFill/>
+          <a:ln/>
+        </p:spPr>
+        <p:txBody>
+          <a:bodyPr wrap="square" lIns="0" tIns="0" rIns="0" bIns="0" rtlCol="0" anchor="t"/>
+          <a:lstStyle/>
+          <a:p>
+            <a:pPr algn="l" indent="0" marL="0">
+              <a:lnSpc>
+                <a:spcPct val="102000"/>
+              </a:lnSpc>
+              <a:buNone/>
+            </a:pPr>
+            <a:r>
+              <a:rPr lang="en-US" sz="430" b="1" dirty="0">
+                <a:solidFill>
+                  <a:srgbClr val="202124"/>
+                </a:solidFill>
+                <a:latin typeface="Arial" pitchFamily="34" charset="0"/>
+                <a:ea typeface="Arial" pitchFamily="34" charset="-122"/>
+                <a:cs typeface="Arial" pitchFamily="34" charset="-120"/>
+              </a:rPr>
+              <a:t>Central governance and FinOps observability hub</a:t>
+            </a:r>
+            <a:endParaRPr lang="en-US" sz="430" dirty="0"/>
+          </a:p>
+        </p:txBody>
+      </p:sp>
+      <p:sp>
+        <p:nvSpPr>
+          <p:cNvPr id="134" name="Shape 131"/>
           <p:cNvSpPr/>
           <p:nvPr/>
         </p:nvSpPr>
@@ -23656,7 +23736,7 @@
       </p:sp>
       <p:pic>
         <p:nvPicPr>
-          <p:cNvPr id="131" name="Image 1" descr="preencoded.png">    </p:cNvPr>
+          <p:cNvPr id="135" name="Image 1" descr="preencoded.png">    </p:cNvPr>
           <p:cNvPicPr>
             <a:picLocks noChangeAspect="1"/>
           </p:cNvPicPr>
@@ -23680,7 +23760,7 @@
       </p:pic>
       <p:sp>
         <p:nvSpPr>
-          <p:cNvPr id="132" name="Text 128"/>
+          <p:cNvPr id="136" name="Text 132"/>
           <p:cNvSpPr/>
           <p:nvPr/>
         </p:nvSpPr>
@@ -23742,7 +23822,7 @@
       </p:sp>
       <p:sp>
         <p:nvSpPr>
-          <p:cNvPr id="133" name="Shape 129"/>
+          <p:cNvPr id="137" name="Shape 133"/>
           <p:cNvSpPr/>
           <p:nvPr/>
         </p:nvSpPr>
@@ -23769,7 +23849,7 @@
       </p:sp>
       <p:pic>
         <p:nvPicPr>
-          <p:cNvPr id="134" name="Image 2" descr="preencoded.png">    </p:cNvPr>
+          <p:cNvPr id="138" name="Image 2" descr="preencoded.png">    </p:cNvPr>
           <p:cNvPicPr>
             <a:picLocks noChangeAspect="1"/>
           </p:cNvPicPr>
@@ -23793,7 +23873,7 @@
       </p:pic>
       <p:sp>
         <p:nvSpPr>
-          <p:cNvPr id="135" name="Text 130"/>
+          <p:cNvPr id="139" name="Text 134"/>
           <p:cNvSpPr/>
           <p:nvPr/>
         </p:nvSpPr>
@@ -23855,7 +23935,7 @@
       </p:sp>
       <p:sp>
         <p:nvSpPr>
-          <p:cNvPr id="136" name="Shape 131"/>
+          <p:cNvPr id="140" name="Shape 135"/>
           <p:cNvSpPr/>
           <p:nvPr/>
         </p:nvSpPr>
@@ -23882,7 +23962,7 @@
       </p:sp>
       <p:pic>
         <p:nvPicPr>
-          <p:cNvPr id="137" name="Image 3" descr="preencoded.png">    </p:cNvPr>
+          <p:cNvPr id="141" name="Image 3" descr="preencoded.png">    </p:cNvPr>
           <p:cNvPicPr>
             <a:picLocks noChangeAspect="1"/>
           </p:cNvPicPr>
@@ -23906,7 +23986,7 @@
       </p:pic>
       <p:sp>
         <p:nvSpPr>
-          <p:cNvPr id="138" name="Text 132"/>
+          <p:cNvPr id="142" name="Text 136"/>
           <p:cNvSpPr/>
           <p:nvPr/>
         </p:nvSpPr>
@@ -23968,7 +24048,7 @@
       </p:sp>
       <p:sp>
         <p:nvSpPr>
-          <p:cNvPr id="139" name="Shape 133"/>
+          <p:cNvPr id="143" name="Shape 137"/>
           <p:cNvSpPr/>
           <p:nvPr/>
         </p:nvSpPr>
@@ -23995,7 +24075,7 @@
       </p:sp>
       <p:pic>
         <p:nvPicPr>
-          <p:cNvPr id="140" name="Image 4" descr="preencoded.png">    </p:cNvPr>
+          <p:cNvPr id="144" name="Image 4" descr="preencoded.png">    </p:cNvPr>
           <p:cNvPicPr>
             <a:picLocks noChangeAspect="1"/>
           </p:cNvPicPr>
@@ -24019,7 +24099,7 @@
       </p:pic>
       <p:sp>
         <p:nvSpPr>
-          <p:cNvPr id="141" name="Text 134"/>
+          <p:cNvPr id="145" name="Text 138"/>
           <p:cNvSpPr/>
           <p:nvPr/>
         </p:nvSpPr>
@@ -24081,7 +24161,7 @@
       </p:sp>
       <p:sp>
         <p:nvSpPr>
-          <p:cNvPr id="142" name="Shape 135"/>
+          <p:cNvPr id="146" name="Shape 139"/>
           <p:cNvSpPr/>
           <p:nvPr/>
         </p:nvSpPr>
@@ -24108,7 +24188,7 @@
       </p:sp>
       <p:pic>
         <p:nvPicPr>
-          <p:cNvPr id="143" name="Image 5" descr="preencoded.png">    </p:cNvPr>
+          <p:cNvPr id="147" name="Image 5" descr="preencoded.png">    </p:cNvPr>
           <p:cNvPicPr>
             <a:picLocks noChangeAspect="1"/>
           </p:cNvPicPr>
@@ -24132,7 +24212,7 @@
       </p:pic>
       <p:sp>
         <p:nvSpPr>
-          <p:cNvPr id="144" name="Text 136"/>
+          <p:cNvPr id="148" name="Text 140"/>
           <p:cNvSpPr/>
           <p:nvPr/>
         </p:nvSpPr>
@@ -24194,7 +24274,7 @@
       </p:sp>
       <p:sp>
         <p:nvSpPr>
-          <p:cNvPr id="145" name="Shape 137"/>
+          <p:cNvPr id="149" name="Shape 141"/>
           <p:cNvSpPr/>
           <p:nvPr/>
         </p:nvSpPr>
@@ -24221,7 +24301,7 @@
       </p:sp>
       <p:pic>
         <p:nvPicPr>
-          <p:cNvPr id="146" name="Image 6" descr="preencoded.png">    </p:cNvPr>
+          <p:cNvPr id="150" name="Image 6" descr="preencoded.png">    </p:cNvPr>
           <p:cNvPicPr>
             <a:picLocks noChangeAspect="1"/>
           </p:cNvPicPr>
@@ -24245,7 +24325,7 @@
       </p:pic>
       <p:sp>
         <p:nvSpPr>
-          <p:cNvPr id="147" name="Text 138"/>
+          <p:cNvPr id="151" name="Text 142"/>
           <p:cNvSpPr/>
           <p:nvPr/>
         </p:nvSpPr>
@@ -24307,7 +24387,7 @@
       </p:sp>
       <p:sp>
         <p:nvSpPr>
-          <p:cNvPr id="148" name="Shape 139"/>
+          <p:cNvPr id="152" name="Shape 143"/>
           <p:cNvSpPr/>
           <p:nvPr/>
         </p:nvSpPr>
@@ -24334,7 +24414,7 @@
       </p:sp>
       <p:pic>
         <p:nvPicPr>
-          <p:cNvPr id="149" name="Image 7" descr="preencoded.png">    </p:cNvPr>
+          <p:cNvPr id="153" name="Image 7" descr="preencoded.png">    </p:cNvPr>
           <p:cNvPicPr>
             <a:picLocks noChangeAspect="1"/>
           </p:cNvPicPr>
@@ -24358,7 +24438,7 @@
       </p:pic>
       <p:sp>
         <p:nvSpPr>
-          <p:cNvPr id="150" name="Text 140"/>
+          <p:cNvPr id="154" name="Text 144"/>
           <p:cNvSpPr/>
           <p:nvPr/>
         </p:nvSpPr>
@@ -24420,7 +24500,7 @@
       </p:sp>
       <p:sp>
         <p:nvSpPr>
-          <p:cNvPr id="151" name="Shape 141"/>
+          <p:cNvPr id="155" name="Shape 145"/>
           <p:cNvSpPr/>
           <p:nvPr/>
         </p:nvSpPr>
@@ -24447,7 +24527,7 @@
       </p:sp>
       <p:pic>
         <p:nvPicPr>
-          <p:cNvPr id="152" name="Image 8" descr="preencoded.png">    </p:cNvPr>
+          <p:cNvPr id="156" name="Image 8" descr="preencoded.png">    </p:cNvPr>
           <p:cNvPicPr>
             <a:picLocks noChangeAspect="1"/>
           </p:cNvPicPr>
@@ -24471,7 +24551,7 @@
       </p:pic>
       <p:sp>
         <p:nvSpPr>
-          <p:cNvPr id="153" name="Text 142"/>
+          <p:cNvPr id="157" name="Text 146"/>
           <p:cNvSpPr/>
           <p:nvPr/>
         </p:nvSpPr>
@@ -24533,7 +24613,7 @@
       </p:sp>
       <p:sp>
         <p:nvSpPr>
-          <p:cNvPr id="154" name="Shape 143"/>
+          <p:cNvPr id="158" name="Shape 147"/>
           <p:cNvSpPr/>
           <p:nvPr/>
         </p:nvSpPr>
@@ -24560,7 +24640,7 @@
       </p:sp>
       <p:pic>
         <p:nvPicPr>
-          <p:cNvPr id="155" name="Image 9" descr="preencoded.png">    </p:cNvPr>
+          <p:cNvPr id="159" name="Image 9" descr="preencoded.png">    </p:cNvPr>
           <p:cNvPicPr>
             <a:picLocks noChangeAspect="1"/>
           </p:cNvPicPr>
@@ -24584,7 +24664,7 @@
       </p:pic>
       <p:sp>
         <p:nvSpPr>
-          <p:cNvPr id="156" name="Text 144"/>
+          <p:cNvPr id="160" name="Text 148"/>
           <p:cNvSpPr/>
           <p:nvPr/>
         </p:nvSpPr>
@@ -24646,7 +24726,7 @@
       </p:sp>
       <p:sp>
         <p:nvSpPr>
-          <p:cNvPr id="157" name="Shape 145"/>
+          <p:cNvPr id="161" name="Shape 149"/>
           <p:cNvSpPr/>
           <p:nvPr/>
         </p:nvSpPr>
@@ -24673,7 +24753,7 @@
       </p:sp>
       <p:pic>
         <p:nvPicPr>
-          <p:cNvPr id="158" name="Image 10" descr="preencoded.png">    </p:cNvPr>
+          <p:cNvPr id="162" name="Image 10" descr="preencoded.png">    </p:cNvPr>
           <p:cNvPicPr>
             <a:picLocks noChangeAspect="1"/>
           </p:cNvPicPr>
@@ -24697,7 +24777,7 @@
       </p:pic>
       <p:sp>
         <p:nvSpPr>
-          <p:cNvPr id="159" name="Text 146"/>
+          <p:cNvPr id="163" name="Text 150"/>
           <p:cNvSpPr/>
           <p:nvPr/>
         </p:nvSpPr>
@@ -24759,7 +24839,7 @@
       </p:sp>
       <p:sp>
         <p:nvSpPr>
-          <p:cNvPr id="160" name="Shape 147"/>
+          <p:cNvPr id="164" name="Shape 151"/>
           <p:cNvSpPr/>
           <p:nvPr/>
         </p:nvSpPr>
@@ -24786,7 +24866,7 @@
       </p:sp>
       <p:pic>
         <p:nvPicPr>
-          <p:cNvPr id="161" name="Image 11" descr="preencoded.png">    </p:cNvPr>
+          <p:cNvPr id="165" name="Image 11" descr="preencoded.png">    </p:cNvPr>
           <p:cNvPicPr>
             <a:picLocks noChangeAspect="1"/>
           </p:cNvPicPr>
@@ -24810,7 +24890,7 @@
       </p:pic>
       <p:sp>
         <p:nvSpPr>
-          <p:cNvPr id="162" name="Text 148"/>
+          <p:cNvPr id="166" name="Text 152"/>
           <p:cNvSpPr/>
           <p:nvPr/>
         </p:nvSpPr>
@@ -24872,7 +24952,7 @@
       </p:sp>
       <p:sp>
         <p:nvSpPr>
-          <p:cNvPr id="163" name="Shape 149"/>
+          <p:cNvPr id="167" name="Shape 153"/>
           <p:cNvSpPr/>
           <p:nvPr/>
         </p:nvSpPr>
@@ -24899,7 +24979,7 @@
       </p:sp>
       <p:pic>
         <p:nvPicPr>
-          <p:cNvPr id="164" name="Image 12" descr="preencoded.png">    </p:cNvPr>
+          <p:cNvPr id="168" name="Image 12" descr="preencoded.png">    </p:cNvPr>
           <p:cNvPicPr>
             <a:picLocks noChangeAspect="1"/>
           </p:cNvPicPr>
@@ -24923,7 +25003,7 @@
       </p:pic>
       <p:sp>
         <p:nvSpPr>
-          <p:cNvPr id="165" name="Text 150"/>
+          <p:cNvPr id="169" name="Text 154"/>
           <p:cNvSpPr/>
           <p:nvPr/>
         </p:nvSpPr>
@@ -24985,7 +25065,7 @@
       </p:sp>
       <p:sp>
         <p:nvSpPr>
-          <p:cNvPr id="166" name="Shape 151"/>
+          <p:cNvPr id="170" name="Shape 155"/>
           <p:cNvSpPr/>
           <p:nvPr/>
         </p:nvSpPr>
@@ -25012,7 +25092,7 @@
       </p:sp>
       <p:pic>
         <p:nvPicPr>
-          <p:cNvPr id="167" name="Image 13" descr="preencoded.png">    </p:cNvPr>
+          <p:cNvPr id="171" name="Image 13" descr="preencoded.png">    </p:cNvPr>
           <p:cNvPicPr>
             <a:picLocks noChangeAspect="1"/>
           </p:cNvPicPr>
@@ -25036,7 +25116,7 @@
       </p:pic>
       <p:sp>
         <p:nvSpPr>
-          <p:cNvPr id="168" name="Text 152"/>
+          <p:cNvPr id="172" name="Text 156"/>
           <p:cNvSpPr/>
           <p:nvPr/>
         </p:nvSpPr>
@@ -25098,7 +25178,7 @@
       </p:sp>
       <p:sp>
         <p:nvSpPr>
-          <p:cNvPr id="169" name="Shape 153"/>
+          <p:cNvPr id="173" name="Shape 157"/>
           <p:cNvSpPr/>
           <p:nvPr/>
         </p:nvSpPr>
@@ -25125,7 +25205,7 @@
       </p:sp>
       <p:pic>
         <p:nvPicPr>
-          <p:cNvPr id="170" name="Image 14" descr="preencoded.png">    </p:cNvPr>
+          <p:cNvPr id="174" name="Image 14" descr="preencoded.png">    </p:cNvPr>
           <p:cNvPicPr>
             <a:picLocks noChangeAspect="1"/>
           </p:cNvPicPr>
@@ -25149,7 +25229,7 @@
       </p:pic>
       <p:sp>
         <p:nvSpPr>
-          <p:cNvPr id="171" name="Text 154"/>
+          <p:cNvPr id="175" name="Text 158"/>
           <p:cNvSpPr/>
           <p:nvPr/>
         </p:nvSpPr>
@@ -25211,7 +25291,7 @@
       </p:sp>
       <p:sp>
         <p:nvSpPr>
-          <p:cNvPr id="172" name="Shape 155"/>
+          <p:cNvPr id="176" name="Shape 159"/>
           <p:cNvSpPr/>
           <p:nvPr/>
         </p:nvSpPr>
@@ -25238,7 +25318,7 @@
       </p:sp>
       <p:pic>
         <p:nvPicPr>
-          <p:cNvPr id="173" name="Image 15" descr="preencoded.png">    </p:cNvPr>
+          <p:cNvPr id="177" name="Image 15" descr="preencoded.png">    </p:cNvPr>
           <p:cNvPicPr>
             <a:picLocks noChangeAspect="1"/>
           </p:cNvPicPr>
@@ -25262,7 +25342,7 @@
       </p:pic>
       <p:sp>
         <p:nvSpPr>
-          <p:cNvPr id="174" name="Text 156"/>
+          <p:cNvPr id="178" name="Text 160"/>
           <p:cNvSpPr/>
           <p:nvPr/>
         </p:nvSpPr>
@@ -25324,7 +25404,7 @@
       </p:sp>
       <p:sp>
         <p:nvSpPr>
-          <p:cNvPr id="175" name="Shape 157"/>
+          <p:cNvPr id="179" name="Shape 161"/>
           <p:cNvSpPr/>
           <p:nvPr/>
         </p:nvSpPr>
@@ -25351,7 +25431,7 @@
       </p:sp>
       <p:pic>
         <p:nvPicPr>
-          <p:cNvPr id="176" name="Image 16" descr="preencoded.png">    </p:cNvPr>
+          <p:cNvPr id="180" name="Image 16" descr="preencoded.png">    </p:cNvPr>
           <p:cNvPicPr>
             <a:picLocks noChangeAspect="1"/>
           </p:cNvPicPr>
@@ -25375,7 +25455,7 @@
       </p:pic>
       <p:sp>
         <p:nvSpPr>
-          <p:cNvPr id="177" name="Text 158"/>
+          <p:cNvPr id="181" name="Text 162"/>
           <p:cNvSpPr/>
           <p:nvPr/>
         </p:nvSpPr>
@@ -25437,7 +25517,7 @@
       </p:sp>
       <p:sp>
         <p:nvSpPr>
-          <p:cNvPr id="178" name="Shape 159"/>
+          <p:cNvPr id="182" name="Shape 163"/>
           <p:cNvSpPr/>
           <p:nvPr/>
         </p:nvSpPr>
@@ -25464,7 +25544,7 @@
       </p:sp>
       <p:pic>
         <p:nvPicPr>
-          <p:cNvPr id="179" name="Image 17" descr="preencoded.png">    </p:cNvPr>
+          <p:cNvPr id="183" name="Image 17" descr="preencoded.png">    </p:cNvPr>
           <p:cNvPicPr>
             <a:picLocks noChangeAspect="1"/>
           </p:cNvPicPr>
@@ -25488,7 +25568,7 @@
       </p:pic>
       <p:sp>
         <p:nvSpPr>
-          <p:cNvPr id="180" name="Text 160"/>
+          <p:cNvPr id="184" name="Text 164"/>
           <p:cNvSpPr/>
           <p:nvPr/>
         </p:nvSpPr>
@@ -25550,7 +25630,7 @@
       </p:sp>
       <p:sp>
         <p:nvSpPr>
-          <p:cNvPr id="181" name="Shape 161"/>
+          <p:cNvPr id="185" name="Shape 165"/>
           <p:cNvSpPr/>
           <p:nvPr/>
         </p:nvSpPr>
@@ -25577,7 +25657,7 @@
       </p:sp>
       <p:pic>
         <p:nvPicPr>
-          <p:cNvPr id="182" name="Image 18" descr="preencoded.png">    </p:cNvPr>
+          <p:cNvPr id="186" name="Image 18" descr="preencoded.png">    </p:cNvPr>
           <p:cNvPicPr>
             <a:picLocks noChangeAspect="1"/>
           </p:cNvPicPr>
@@ -25601,7 +25681,7 @@
       </p:pic>
       <p:sp>
         <p:nvSpPr>
-          <p:cNvPr id="183" name="Text 162"/>
+          <p:cNvPr id="187" name="Text 166"/>
           <p:cNvSpPr/>
           <p:nvPr/>
         </p:nvSpPr>
@@ -25663,7 +25743,7 @@
       </p:sp>
       <p:sp>
         <p:nvSpPr>
-          <p:cNvPr id="184" name="Shape 163"/>
+          <p:cNvPr id="188" name="Shape 167"/>
           <p:cNvSpPr/>
           <p:nvPr/>
         </p:nvSpPr>
@@ -25690,7 +25770,7 @@
       </p:sp>
       <p:pic>
         <p:nvPicPr>
-          <p:cNvPr id="185" name="Image 19" descr="preencoded.png">    </p:cNvPr>
+          <p:cNvPr id="189" name="Image 19" descr="preencoded.png">    </p:cNvPr>
           <p:cNvPicPr>
             <a:picLocks noChangeAspect="1"/>
           </p:cNvPicPr>
@@ -25714,7 +25794,7 @@
       </p:pic>
       <p:sp>
         <p:nvSpPr>
-          <p:cNvPr id="186" name="Text 164"/>
+          <p:cNvPr id="190" name="Text 168"/>
           <p:cNvSpPr/>
           <p:nvPr/>
         </p:nvSpPr>
@@ -25776,7 +25856,7 @@
       </p:sp>
       <p:sp>
         <p:nvSpPr>
-          <p:cNvPr id="187" name="Shape 165"/>
+          <p:cNvPr id="191" name="Shape 169"/>
           <p:cNvSpPr/>
           <p:nvPr/>
         </p:nvSpPr>
@@ -25801,7 +25881,7 @@
       </p:sp>
       <p:sp>
         <p:nvSpPr>
-          <p:cNvPr id="188" name="Text 166"/>
+          <p:cNvPr id="192" name="Text 170"/>
           <p:cNvSpPr/>
           <p:nvPr/>
         </p:nvSpPr>
@@ -25840,7 +25920,7 @@
       </p:sp>
       <p:sp>
         <p:nvSpPr>
-          <p:cNvPr id="189" name="Shape 167"/>
+          <p:cNvPr id="193" name="Shape 171"/>
           <p:cNvSpPr/>
           <p:nvPr/>
         </p:nvSpPr>
@@ -25865,7 +25945,7 @@
       </p:sp>
       <p:sp>
         <p:nvSpPr>
-          <p:cNvPr id="190" name="Text 168"/>
+          <p:cNvPr id="194" name="Text 172"/>
           <p:cNvSpPr/>
           <p:nvPr/>
         </p:nvSpPr>
@@ -25904,7 +25984,7 @@
       </p:sp>
       <p:sp>
         <p:nvSpPr>
-          <p:cNvPr id="191" name="Shape 169"/>
+          <p:cNvPr id="195" name="Shape 173"/>
           <p:cNvSpPr/>
           <p:nvPr/>
         </p:nvSpPr>
@@ -25929,7 +26009,7 @@
       </p:sp>
       <p:sp>
         <p:nvSpPr>
-          <p:cNvPr id="192" name="Text 170"/>
+          <p:cNvPr id="196" name="Text 174"/>
           <p:cNvSpPr/>
           <p:nvPr/>
         </p:nvSpPr>
@@ -25968,7 +26048,7 @@
       </p:sp>
       <p:sp>
         <p:nvSpPr>
-          <p:cNvPr id="193" name="Shape 171"/>
+          <p:cNvPr id="197" name="Shape 175"/>
           <p:cNvSpPr/>
           <p:nvPr/>
         </p:nvSpPr>
@@ -25993,7 +26073,7 @@
       </p:sp>
       <p:sp>
         <p:nvSpPr>
-          <p:cNvPr id="194" name="Text 172"/>
+          <p:cNvPr id="198" name="Text 176"/>
           <p:cNvSpPr/>
           <p:nvPr/>
         </p:nvSpPr>
@@ -26032,7 +26112,7 @@
       </p:sp>
       <p:sp>
         <p:nvSpPr>
-          <p:cNvPr id="195" name="Shape 173"/>
+          <p:cNvPr id="199" name="Shape 177"/>
           <p:cNvSpPr/>
           <p:nvPr/>
         </p:nvSpPr>
@@ -26057,7 +26137,7 @@
       </p:sp>
       <p:sp>
         <p:nvSpPr>
-          <p:cNvPr id="196" name="Text 174"/>
+          <p:cNvPr id="200" name="Text 178"/>
           <p:cNvSpPr/>
           <p:nvPr/>
         </p:nvSpPr>
@@ -26096,7 +26176,7 @@
       </p:sp>
       <p:sp>
         <p:nvSpPr>
-          <p:cNvPr id="197" name="Shape 175"/>
+          <p:cNvPr id="201" name="Shape 179"/>
           <p:cNvSpPr/>
           <p:nvPr/>
         </p:nvSpPr>
@@ -26121,7 +26201,7 @@
       </p:sp>
       <p:sp>
         <p:nvSpPr>
-          <p:cNvPr id="198" name="Text 176"/>
+          <p:cNvPr id="202" name="Text 180"/>
           <p:cNvSpPr/>
           <p:nvPr/>
         </p:nvSpPr>
@@ -26160,7 +26240,7 @@
       </p:sp>
       <p:sp>
         <p:nvSpPr>
-          <p:cNvPr id="199" name="Shape 177"/>
+          <p:cNvPr id="203" name="Shape 181"/>
           <p:cNvSpPr/>
           <p:nvPr/>
         </p:nvSpPr>
@@ -26185,7 +26265,7 @@
       </p:sp>
       <p:sp>
         <p:nvSpPr>
-          <p:cNvPr id="200" name="Text 178"/>
+          <p:cNvPr id="204" name="Text 182"/>
           <p:cNvSpPr/>
           <p:nvPr/>
         </p:nvSpPr>
@@ -26224,7 +26304,7 @@
       </p:sp>
       <p:sp>
         <p:nvSpPr>
-          <p:cNvPr id="201" name="Shape 179"/>
+          <p:cNvPr id="205" name="Shape 183"/>
           <p:cNvSpPr/>
           <p:nvPr/>
         </p:nvSpPr>
@@ -26249,7 +26329,7 @@
       </p:sp>
       <p:sp>
         <p:nvSpPr>
-          <p:cNvPr id="202" name="Text 180"/>
+          <p:cNvPr id="206" name="Text 184"/>
           <p:cNvSpPr/>
           <p:nvPr/>
         </p:nvSpPr>
@@ -26288,7 +26368,7 @@
       </p:sp>
       <p:sp>
         <p:nvSpPr>
-          <p:cNvPr id="203" name="Shape 181"/>
+          <p:cNvPr id="207" name="Shape 185"/>
           <p:cNvSpPr/>
           <p:nvPr/>
         </p:nvSpPr>
@@ -26313,7 +26393,7 @@
       </p:sp>
       <p:sp>
         <p:nvSpPr>
-          <p:cNvPr id="204" name="Text 182"/>
+          <p:cNvPr id="208" name="Text 186"/>
           <p:cNvSpPr/>
           <p:nvPr/>
         </p:nvSpPr>
@@ -26352,18 +26432,18 @@
       </p:sp>
       <p:sp>
         <p:nvSpPr>
-          <p:cNvPr id="205" name="Shape 183"/>
-          <p:cNvSpPr/>
-          <p:nvPr/>
-        </p:nvSpPr>
-        <p:spPr>
-          <a:xfrm>
-            <a:off x="5339182" y="3353105"/>
-            <a:ext cx="760781" cy="217627"/>
+          <p:cNvPr id="209" name="Shape 187"/>
+          <p:cNvSpPr/>
+          <p:nvPr/>
+        </p:nvSpPr>
+        <p:spPr>
+          <a:xfrm>
+            <a:off x="5339182" y="3390595"/>
+            <a:ext cx="736092" cy="142646"/>
           </a:xfrm>
           <a:prstGeom prst="roundRect">
             <a:avLst>
-              <a:gd name="adj" fmla="val 21008"/>
+              <a:gd name="adj" fmla="val 28846"/>
             </a:avLst>
           </a:prstGeom>
           <a:solidFill>
@@ -26379,14 +26459,14 @@
       </p:sp>
       <p:sp>
         <p:nvSpPr>
-          <p:cNvPr id="206" name="Text 184"/>
-          <p:cNvSpPr/>
-          <p:nvPr/>
-        </p:nvSpPr>
-        <p:spPr>
-          <a:xfrm>
-            <a:off x="5359298" y="3362249"/>
-            <a:ext cx="720547" cy="199339"/>
+          <p:cNvPr id="210" name="Text 188"/>
+          <p:cNvSpPr/>
+          <p:nvPr/>
+        </p:nvSpPr>
+        <p:spPr>
+          <a:xfrm>
+            <a:off x="5357470" y="3396082"/>
+            <a:ext cx="699516" cy="131674"/>
           </a:xfrm>
           <a:prstGeom prst="rect">
             <a:avLst/>
@@ -26400,12 +26480,12 @@
           <a:p>
             <a:pPr algn="ctr" indent="0" marL="0">
               <a:lnSpc>
-                <a:spcPct val="102000"/>
+                <a:spcPct val="100000"/>
               </a:lnSpc>
               <a:buNone/>
             </a:pPr>
             <a:r>
-              <a:rPr lang="en-US" sz="410" b="1" dirty="0">
+              <a:rPr lang="en-US" sz="385" b="1" dirty="0">
                 <a:solidFill>
                   <a:srgbClr val="202124"/>
                 </a:solidFill>
@@ -26415,17 +26495,17 @@
               </a:rPr>
               <a:t>Security, OTel &amp; FinOps</a:t>
             </a:r>
-            <a:endParaRPr lang="en-US" sz="410" dirty="0"/>
+            <a:endParaRPr lang="en-US" sz="385" dirty="0"/>
           </a:p>
           <a:p>
             <a:pPr algn="ctr" indent="0" marL="0">
               <a:lnSpc>
-                <a:spcPct val="102000"/>
+                <a:spcPct val="100000"/>
               </a:lnSpc>
               <a:buNone/>
             </a:pPr>
             <a:r>
-              <a:rPr lang="en-US" sz="375" dirty="0">
+              <a:rPr lang="en-US" sz="350" dirty="0">
                 <a:solidFill>
                   <a:srgbClr val="202124"/>
                 </a:solidFill>
@@ -26435,24 +26515,24 @@
               </a:rPr>
               <a:t>chargeback telemetry</a:t>
             </a:r>
-            <a:endParaRPr lang="en-US" sz="410" dirty="0"/>
-          </a:p>
-        </p:txBody>
-      </p:sp>
-      <p:sp>
-        <p:nvSpPr>
-          <p:cNvPr id="207" name="Shape 185"/>
-          <p:cNvSpPr/>
-          <p:nvPr/>
-        </p:nvSpPr>
-        <p:spPr>
-          <a:xfrm>
-            <a:off x="2884932" y="4817974"/>
-            <a:ext cx="397764" cy="208483"/>
+            <a:endParaRPr lang="en-US" sz="385" dirty="0"/>
+          </a:p>
+        </p:txBody>
+      </p:sp>
+      <p:sp>
+        <p:nvSpPr>
+          <p:cNvPr id="211" name="Shape 189"/>
+          <p:cNvSpPr/>
+          <p:nvPr/>
+        </p:nvSpPr>
+        <p:spPr>
+          <a:xfrm>
+            <a:off x="2896819" y="4850892"/>
+            <a:ext cx="372161" cy="142646"/>
           </a:xfrm>
           <a:prstGeom prst="roundRect">
             <a:avLst>
-              <a:gd name="adj" fmla="val 21930"/>
+              <a:gd name="adj" fmla="val 28846"/>
             </a:avLst>
           </a:prstGeom>
           <a:solidFill>
@@ -26468,14 +26548,14 @@
       </p:sp>
       <p:sp>
         <p:nvSpPr>
-          <p:cNvPr id="208" name="Text 186"/>
-          <p:cNvSpPr/>
-          <p:nvPr/>
-        </p:nvSpPr>
-        <p:spPr>
-          <a:xfrm>
-            <a:off x="2905049" y="4827118"/>
-            <a:ext cx="357530" cy="190195"/>
+          <p:cNvPr id="212" name="Text 190"/>
+          <p:cNvSpPr/>
+          <p:nvPr/>
+        </p:nvSpPr>
+        <p:spPr>
+          <a:xfrm>
+            <a:off x="2915107" y="4856378"/>
+            <a:ext cx="335585" cy="131674"/>
           </a:xfrm>
           <a:prstGeom prst="rect">
             <a:avLst/>
@@ -26489,12 +26569,12 @@
           <a:p>
             <a:pPr algn="ctr" indent="0" marL="0">
               <a:lnSpc>
-                <a:spcPct val="102000"/>
+                <a:spcPct val="100000"/>
               </a:lnSpc>
               <a:buNone/>
             </a:pPr>
             <a:r>
-              <a:rPr lang="en-US" sz="410" b="1" dirty="0">
+              <a:rPr lang="en-US" sz="385" b="1" dirty="0">
                 <a:solidFill>
                   <a:srgbClr val="202124"/>
                 </a:solidFill>
@@ -26504,17 +26584,17 @@
               </a:rPr>
               <a:t>Scoped</a:t>
             </a:r>
-            <a:endParaRPr lang="en-US" sz="410" dirty="0"/>
+            <a:endParaRPr lang="en-US" sz="385" dirty="0"/>
           </a:p>
           <a:p>
             <a:pPr algn="ctr" indent="0" marL="0">
               <a:lnSpc>
-                <a:spcPct val="102000"/>
+                <a:spcPct val="100000"/>
               </a:lnSpc>
               <a:buNone/>
             </a:pPr>
             <a:r>
-              <a:rPr lang="en-US" sz="375" dirty="0">
+              <a:rPr lang="en-US" sz="350" dirty="0">
                 <a:solidFill>
                   <a:srgbClr val="202124"/>
                 </a:solidFill>
@@ -26524,24 +26604,24 @@
               </a:rPr>
               <a:t>MCP &amp; RAG</a:t>
             </a:r>
-            <a:endParaRPr lang="en-US" sz="410" dirty="0"/>
-          </a:p>
-        </p:txBody>
-      </p:sp>
-      <p:sp>
-        <p:nvSpPr>
-          <p:cNvPr id="209" name="Shape 187"/>
-          <p:cNvSpPr/>
-          <p:nvPr/>
-        </p:nvSpPr>
-        <p:spPr>
-          <a:xfrm>
-            <a:off x="2815438" y="5452567"/>
-            <a:ext cx="534924" cy="208483"/>
+            <a:endParaRPr lang="en-US" sz="385" dirty="0"/>
+          </a:p>
+        </p:txBody>
+      </p:sp>
+      <p:sp>
+        <p:nvSpPr>
+          <p:cNvPr id="213" name="Shape 191"/>
+          <p:cNvSpPr/>
+          <p:nvPr/>
+        </p:nvSpPr>
+        <p:spPr>
+          <a:xfrm>
+            <a:off x="2831897" y="5485486"/>
+            <a:ext cx="502006" cy="142646"/>
           </a:xfrm>
           <a:prstGeom prst="roundRect">
             <a:avLst>
-              <a:gd name="adj" fmla="val 21930"/>
+              <a:gd name="adj" fmla="val 28846"/>
             </a:avLst>
           </a:prstGeom>
           <a:solidFill>
@@ -26557,14 +26637,14 @@
       </p:sp>
       <p:sp>
         <p:nvSpPr>
-          <p:cNvPr id="210" name="Text 188"/>
-          <p:cNvSpPr/>
-          <p:nvPr/>
-        </p:nvSpPr>
-        <p:spPr>
-          <a:xfrm>
-            <a:off x="2835554" y="5461711"/>
-            <a:ext cx="494690" cy="190195"/>
+          <p:cNvPr id="214" name="Text 192"/>
+          <p:cNvSpPr/>
+          <p:nvPr/>
+        </p:nvSpPr>
+        <p:spPr>
+          <a:xfrm>
+            <a:off x="2850185" y="5490972"/>
+            <a:ext cx="465430" cy="131674"/>
           </a:xfrm>
           <a:prstGeom prst="rect">
             <a:avLst/>
@@ -26578,12 +26658,12 @@
           <a:p>
             <a:pPr algn="ctr" indent="0" marL="0">
               <a:lnSpc>
-                <a:spcPct val="102000"/>
+                <a:spcPct val="100000"/>
               </a:lnSpc>
               <a:buNone/>
             </a:pPr>
             <a:r>
-              <a:rPr lang="en-US" sz="410" b="1" dirty="0">
+              <a:rPr lang="en-US" sz="385" b="1" dirty="0">
                 <a:solidFill>
                   <a:srgbClr val="202124"/>
                 </a:solidFill>
@@ -26593,17 +26673,17 @@
               </a:rPr>
               <a:t>SET LOCAL</a:t>
             </a:r>
-            <a:endParaRPr lang="en-US" sz="410" dirty="0"/>
+            <a:endParaRPr lang="en-US" sz="385" dirty="0"/>
           </a:p>
           <a:p>
             <a:pPr algn="ctr" indent="0" marL="0">
               <a:lnSpc>
-                <a:spcPct val="102000"/>
+                <a:spcPct val="100000"/>
               </a:lnSpc>
               <a:buNone/>
             </a:pPr>
             <a:r>
-              <a:rPr lang="en-US" sz="375" dirty="0">
+              <a:rPr lang="en-US" sz="350" dirty="0">
                 <a:solidFill>
                   <a:srgbClr val="202124"/>
                 </a:solidFill>
@@ -26613,24 +26693,24 @@
               </a:rPr>
               <a:t>current_tenant</a:t>
             </a:r>
-            <a:endParaRPr lang="en-US" sz="410" dirty="0"/>
-          </a:p>
-        </p:txBody>
-      </p:sp>
-      <p:sp>
-        <p:nvSpPr>
-          <p:cNvPr id="211" name="Shape 189"/>
-          <p:cNvSpPr/>
-          <p:nvPr/>
-        </p:nvSpPr>
-        <p:spPr>
-          <a:xfrm>
-            <a:off x="5235854" y="4817974"/>
-            <a:ext cx="425196" cy="208483"/>
+            <a:endParaRPr lang="en-US" sz="385" dirty="0"/>
+          </a:p>
+        </p:txBody>
+      </p:sp>
+      <p:sp>
+        <p:nvSpPr>
+          <p:cNvPr id="215" name="Shape 193"/>
+          <p:cNvSpPr/>
+          <p:nvPr/>
+        </p:nvSpPr>
+        <p:spPr>
+          <a:xfrm>
+            <a:off x="5248656" y="4850892"/>
+            <a:ext cx="397764" cy="142646"/>
           </a:xfrm>
           <a:prstGeom prst="roundRect">
             <a:avLst>
-              <a:gd name="adj" fmla="val 21930"/>
+              <a:gd name="adj" fmla="val 28846"/>
             </a:avLst>
           </a:prstGeom>
           <a:solidFill>
@@ -26646,14 +26726,14 @@
       </p:sp>
       <p:sp>
         <p:nvSpPr>
-          <p:cNvPr id="212" name="Text 190"/>
-          <p:cNvSpPr/>
-          <p:nvPr/>
-        </p:nvSpPr>
-        <p:spPr>
-          <a:xfrm>
-            <a:off x="5255971" y="4827118"/>
-            <a:ext cx="384962" cy="190195"/>
+          <p:cNvPr id="216" name="Text 194"/>
+          <p:cNvSpPr/>
+          <p:nvPr/>
+        </p:nvSpPr>
+        <p:spPr>
+          <a:xfrm>
+            <a:off x="5266944" y="4856378"/>
+            <a:ext cx="361188" cy="131674"/>
           </a:xfrm>
           <a:prstGeom prst="rect">
             <a:avLst/>
@@ -26667,12 +26747,12 @@
           <a:p>
             <a:pPr algn="ctr" indent="0" marL="0">
               <a:lnSpc>
-                <a:spcPct val="102000"/>
+                <a:spcPct val="100000"/>
               </a:lnSpc>
               <a:buNone/>
             </a:pPr>
             <a:r>
-              <a:rPr lang="en-US" sz="410" b="1" dirty="0">
+              <a:rPr lang="en-US" sz="385" b="1" dirty="0">
                 <a:solidFill>
                   <a:srgbClr val="202124"/>
                 </a:solidFill>
@@ -26682,17 +26762,17 @@
               </a:rPr>
               <a:t>Air-Gapped</a:t>
             </a:r>
-            <a:endParaRPr lang="en-US" sz="410" dirty="0"/>
+            <a:endParaRPr lang="en-US" sz="385" dirty="0"/>
           </a:p>
           <a:p>
             <a:pPr algn="ctr" indent="0" marL="0">
               <a:lnSpc>
-                <a:spcPct val="102000"/>
+                <a:spcPct val="100000"/>
               </a:lnSpc>
               <a:buNone/>
             </a:pPr>
             <a:r>
-              <a:rPr lang="en-US" sz="375" dirty="0">
+              <a:rPr lang="en-US" sz="350" dirty="0">
                 <a:solidFill>
                   <a:srgbClr val="202124"/>
                 </a:solidFill>
@@ -26702,24 +26782,24 @@
               </a:rPr>
               <a:t>Silo RAG</a:t>
             </a:r>
-            <a:endParaRPr lang="en-US" sz="410" dirty="0"/>
-          </a:p>
-        </p:txBody>
-      </p:sp>
-      <p:sp>
-        <p:nvSpPr>
-          <p:cNvPr id="213" name="Shape 191"/>
-          <p:cNvSpPr/>
-          <p:nvPr/>
-        </p:nvSpPr>
-        <p:spPr>
-          <a:xfrm>
-            <a:off x="5180076" y="5452567"/>
-            <a:ext cx="534924" cy="208483"/>
+            <a:endParaRPr lang="en-US" sz="385" dirty="0"/>
+          </a:p>
+        </p:txBody>
+      </p:sp>
+      <p:sp>
+        <p:nvSpPr>
+          <p:cNvPr id="217" name="Shape 195"/>
+          <p:cNvSpPr/>
+          <p:nvPr/>
+        </p:nvSpPr>
+        <p:spPr>
+          <a:xfrm>
+            <a:off x="5197450" y="5485486"/>
+            <a:ext cx="502006" cy="142646"/>
           </a:xfrm>
           <a:prstGeom prst="roundRect">
             <a:avLst>
-              <a:gd name="adj" fmla="val 21930"/>
+              <a:gd name="adj" fmla="val 28846"/>
             </a:avLst>
           </a:prstGeom>
           <a:solidFill>
@@ -26735,14 +26815,14 @@
       </p:sp>
       <p:sp>
         <p:nvSpPr>
-          <p:cNvPr id="214" name="Text 192"/>
-          <p:cNvSpPr/>
-          <p:nvPr/>
-        </p:nvSpPr>
-        <p:spPr>
-          <a:xfrm>
-            <a:off x="5200193" y="5461711"/>
-            <a:ext cx="494690" cy="190195"/>
+          <p:cNvPr id="218" name="Text 196"/>
+          <p:cNvSpPr/>
+          <p:nvPr/>
+        </p:nvSpPr>
+        <p:spPr>
+          <a:xfrm>
+            <a:off x="5215738" y="5490972"/>
+            <a:ext cx="465430" cy="131674"/>
           </a:xfrm>
           <a:prstGeom prst="rect">
             <a:avLst/>
@@ -26756,12 +26836,12 @@
           <a:p>
             <a:pPr algn="ctr" indent="0" marL="0">
               <a:lnSpc>
-                <a:spcPct val="102000"/>
+                <a:spcPct val="100000"/>
               </a:lnSpc>
               <a:buNone/>
             </a:pPr>
             <a:r>
-              <a:rPr lang="en-US" sz="410" b="1" dirty="0">
+              <a:rPr lang="en-US" sz="385" b="1" dirty="0">
                 <a:solidFill>
                   <a:srgbClr val="202124"/>
                 </a:solidFill>
@@ -26771,17 +26851,17 @@
               </a:rPr>
               <a:t>CMEK-Encrypted</a:t>
             </a:r>
-            <a:endParaRPr lang="en-US" sz="410" dirty="0"/>
+            <a:endParaRPr lang="en-US" sz="385" dirty="0"/>
           </a:p>
           <a:p>
             <a:pPr algn="ctr" indent="0" marL="0">
               <a:lnSpc>
-                <a:spcPct val="102000"/>
+                <a:spcPct val="100000"/>
               </a:lnSpc>
               <a:buNone/>
             </a:pPr>
             <a:r>
-              <a:rPr lang="en-US" sz="375" dirty="0">
+              <a:rPr lang="en-US" sz="350" dirty="0">
                 <a:solidFill>
                   <a:srgbClr val="202124"/>
                 </a:solidFill>
@@ -26791,24 +26871,24 @@
               </a:rPr>
               <a:t>State &amp; Tools</a:t>
             </a:r>
-            <a:endParaRPr lang="en-US" sz="410" dirty="0"/>
-          </a:p>
-        </p:txBody>
-      </p:sp>
-      <p:sp>
-        <p:nvSpPr>
-          <p:cNvPr id="215" name="Shape 193"/>
-          <p:cNvSpPr/>
-          <p:nvPr/>
-        </p:nvSpPr>
-        <p:spPr>
-          <a:xfrm>
-            <a:off x="1757477" y="5604358"/>
-            <a:ext cx="397764" cy="208483"/>
+            <a:endParaRPr lang="en-US" sz="385" dirty="0"/>
+          </a:p>
+        </p:txBody>
+      </p:sp>
+      <p:sp>
+        <p:nvSpPr>
+          <p:cNvPr id="219" name="Shape 197"/>
+          <p:cNvSpPr/>
+          <p:nvPr/>
+        </p:nvSpPr>
+        <p:spPr>
+          <a:xfrm>
+            <a:off x="1757477" y="5637276"/>
+            <a:ext cx="372161" cy="142646"/>
           </a:xfrm>
           <a:prstGeom prst="roundRect">
             <a:avLst>
-              <a:gd name="adj" fmla="val 21930"/>
+              <a:gd name="adj" fmla="val 28846"/>
             </a:avLst>
           </a:prstGeom>
           <a:solidFill>
@@ -26824,14 +26904,14 @@
       </p:sp>
       <p:sp>
         <p:nvSpPr>
-          <p:cNvPr id="216" name="Text 194"/>
-          <p:cNvSpPr/>
-          <p:nvPr/>
-        </p:nvSpPr>
-        <p:spPr>
-          <a:xfrm>
-            <a:off x="1777594" y="5613502"/>
-            <a:ext cx="357530" cy="190195"/>
+          <p:cNvPr id="220" name="Text 198"/>
+          <p:cNvSpPr/>
+          <p:nvPr/>
+        </p:nvSpPr>
+        <p:spPr>
+          <a:xfrm>
+            <a:off x="1775765" y="5642762"/>
+            <a:ext cx="335585" cy="131674"/>
           </a:xfrm>
           <a:prstGeom prst="rect">
             <a:avLst/>
@@ -26845,12 +26925,12 @@
           <a:p>
             <a:pPr algn="ctr" indent="0" marL="0">
               <a:lnSpc>
-                <a:spcPct val="102000"/>
+                <a:spcPct val="100000"/>
               </a:lnSpc>
               <a:buNone/>
             </a:pPr>
             <a:r>
-              <a:rPr lang="en-US" sz="410" b="1" dirty="0">
+              <a:rPr lang="en-US" sz="385" b="1" dirty="0">
                 <a:solidFill>
                   <a:srgbClr val="202124"/>
                 </a:solidFill>
@@ -26860,17 +26940,17 @@
               </a:rPr>
               <a:t>Generates</a:t>
             </a:r>
-            <a:endParaRPr lang="en-US" sz="410" dirty="0"/>
+            <a:endParaRPr lang="en-US" sz="385" dirty="0"/>
           </a:p>
           <a:p>
             <a:pPr algn="ctr" indent="0" marL="0">
               <a:lnSpc>
-                <a:spcPct val="102000"/>
+                <a:spcPct val="100000"/>
               </a:lnSpc>
               <a:buNone/>
             </a:pPr>
             <a:r>
-              <a:rPr lang="en-US" sz="375" dirty="0">
+              <a:rPr lang="en-US" sz="350" dirty="0">
                 <a:solidFill>
                   <a:srgbClr val="202124"/>
                 </a:solidFill>
@@ -26880,24 +26960,24 @@
               </a:rPr>
               <a:t>response</a:t>
             </a:r>
-            <a:endParaRPr lang="en-US" sz="410" dirty="0"/>
-          </a:p>
-        </p:txBody>
-      </p:sp>
-      <p:sp>
-        <p:nvSpPr>
-          <p:cNvPr id="217" name="Shape 195"/>
-          <p:cNvSpPr/>
-          <p:nvPr/>
-        </p:nvSpPr>
-        <p:spPr>
-          <a:xfrm>
-            <a:off x="3905402" y="3354019"/>
-            <a:ext cx="644652" cy="208483"/>
+            <a:endParaRPr lang="en-US" sz="385" dirty="0"/>
+          </a:p>
+        </p:txBody>
+      </p:sp>
+      <p:sp>
+        <p:nvSpPr>
+          <p:cNvPr id="221" name="Shape 199"/>
+          <p:cNvSpPr/>
+          <p:nvPr/>
+        </p:nvSpPr>
+        <p:spPr>
+          <a:xfrm>
+            <a:off x="3905402" y="3389681"/>
+            <a:ext cx="606247" cy="137160"/>
           </a:xfrm>
           <a:prstGeom prst="roundRect">
             <a:avLst>
-              <a:gd name="adj" fmla="val 21930"/>
+              <a:gd name="adj" fmla="val 30000"/>
             </a:avLst>
           </a:prstGeom>
           <a:solidFill>
@@ -26913,14 +26993,14 @@
       </p:sp>
       <p:sp>
         <p:nvSpPr>
-          <p:cNvPr id="218" name="Text 196"/>
-          <p:cNvSpPr/>
-          <p:nvPr/>
-        </p:nvSpPr>
-        <p:spPr>
-          <a:xfrm>
-            <a:off x="3925519" y="3363163"/>
-            <a:ext cx="604418" cy="190195"/>
+          <p:cNvPr id="222" name="Text 200"/>
+          <p:cNvSpPr/>
+          <p:nvPr/>
+        </p:nvSpPr>
+        <p:spPr>
+          <a:xfrm>
+            <a:off x="3923690" y="3395167"/>
+            <a:ext cx="569671" cy="126187"/>
           </a:xfrm>
           <a:prstGeom prst="rect">
             <a:avLst/>
@@ -26934,12 +27014,12 @@
           <a:p>
             <a:pPr algn="ctr" indent="0" marL="0">
               <a:lnSpc>
-                <a:spcPct val="102000"/>
+                <a:spcPct val="100000"/>
               </a:lnSpc>
               <a:buNone/>
             </a:pPr>
             <a:r>
-              <a:rPr lang="en-US" sz="410" b="1" dirty="0">
+              <a:rPr lang="en-US" sz="385" b="1" dirty="0">
                 <a:solidFill>
                   <a:srgbClr val="202124"/>
                 </a:solidFill>
@@ -26949,17 +27029,17 @@
               </a:rPr>
               <a:t>Sanitized response</a:t>
             </a:r>
-            <a:endParaRPr lang="en-US" sz="410" dirty="0"/>
+            <a:endParaRPr lang="en-US" sz="385" dirty="0"/>
           </a:p>
           <a:p>
             <a:pPr algn="ctr" indent="0" marL="0">
               <a:lnSpc>
-                <a:spcPct val="102000"/>
+                <a:spcPct val="100000"/>
               </a:lnSpc>
               <a:buNone/>
             </a:pPr>
             <a:r>
-              <a:rPr lang="en-US" sz="375" dirty="0">
+              <a:rPr lang="en-US" sz="350" dirty="0">
                 <a:solidFill>
                   <a:srgbClr val="202124"/>
                 </a:solidFill>
@@ -26969,24 +27049,24 @@
               </a:rPr>
               <a:t>with SDP redaction</a:t>
             </a:r>
-            <a:endParaRPr lang="en-US" sz="410" dirty="0"/>
-          </a:p>
-        </p:txBody>
-      </p:sp>
-      <p:sp>
-        <p:nvSpPr>
-          <p:cNvPr id="219" name="Shape 197"/>
-          <p:cNvSpPr/>
-          <p:nvPr/>
-        </p:nvSpPr>
-        <p:spPr>
-          <a:xfrm>
-            <a:off x="2983687" y="3354019"/>
-            <a:ext cx="669341" cy="208483"/>
+            <a:endParaRPr lang="en-US" sz="385" dirty="0"/>
+          </a:p>
+        </p:txBody>
+      </p:sp>
+      <p:sp>
+        <p:nvSpPr>
+          <p:cNvPr id="223" name="Shape 201"/>
+          <p:cNvSpPr/>
+          <p:nvPr/>
+        </p:nvSpPr>
+        <p:spPr>
+          <a:xfrm>
+            <a:off x="2983687" y="3389681"/>
+            <a:ext cx="658368" cy="137160"/>
           </a:xfrm>
           <a:prstGeom prst="roundRect">
             <a:avLst>
-              <a:gd name="adj" fmla="val 21930"/>
+              <a:gd name="adj" fmla="val 30000"/>
             </a:avLst>
           </a:prstGeom>
           <a:solidFill>
@@ -27002,14 +27082,14 @@
       </p:sp>
       <p:sp>
         <p:nvSpPr>
-          <p:cNvPr id="220" name="Text 198"/>
-          <p:cNvSpPr/>
-          <p:nvPr/>
-        </p:nvSpPr>
-        <p:spPr>
-          <a:xfrm>
-            <a:off x="3003804" y="3363163"/>
-            <a:ext cx="629107" cy="190195"/>
+          <p:cNvPr id="224" name="Text 202"/>
+          <p:cNvSpPr/>
+          <p:nvPr/>
+        </p:nvSpPr>
+        <p:spPr>
+          <a:xfrm>
+            <a:off x="3001975" y="3395167"/>
+            <a:ext cx="621792" cy="126187"/>
           </a:xfrm>
           <a:prstGeom prst="rect">
             <a:avLst/>
@@ -27023,12 +27103,12 @@
           <a:p>
             <a:pPr algn="ctr" indent="0" marL="0">
               <a:lnSpc>
-                <a:spcPct val="102000"/>
+                <a:spcPct val="100000"/>
               </a:lnSpc>
               <a:buNone/>
             </a:pPr>
             <a:r>
-              <a:rPr lang="en-US" sz="410" b="1" dirty="0">
+              <a:rPr lang="en-US" sz="385" b="1" dirty="0">
                 <a:solidFill>
                   <a:srgbClr val="202124"/>
                 </a:solidFill>
@@ -27038,17 +27118,17 @@
               </a:rPr>
               <a:t>Route by tenant tier</a:t>
             </a:r>
-            <a:endParaRPr lang="en-US" sz="410" dirty="0"/>
+            <a:endParaRPr lang="en-US" sz="385" dirty="0"/>
           </a:p>
           <a:p>
             <a:pPr algn="ctr" indent="0" marL="0">
               <a:lnSpc>
-                <a:spcPct val="102000"/>
+                <a:spcPct val="100000"/>
               </a:lnSpc>
               <a:buNone/>
             </a:pPr>
             <a:r>
-              <a:rPr lang="en-US" sz="375" dirty="0">
+              <a:rPr lang="en-US" sz="350" dirty="0">
                 <a:solidFill>
                   <a:srgbClr val="202124"/>
                 </a:solidFill>
@@ -27058,24 +27138,24 @@
               </a:rPr>
               <a:t>(Pool, Silo or PSC)</a:t>
             </a:r>
-            <a:endParaRPr lang="en-US" sz="410" dirty="0"/>
-          </a:p>
-        </p:txBody>
-      </p:sp>
-      <p:sp>
-        <p:nvSpPr>
-          <p:cNvPr id="221" name="Shape 199"/>
-          <p:cNvSpPr/>
-          <p:nvPr/>
-        </p:nvSpPr>
-        <p:spPr>
-          <a:xfrm>
-            <a:off x="2589581" y="2871216"/>
-            <a:ext cx="425196" cy="208483"/>
+            <a:endParaRPr lang="en-US" sz="385" dirty="0"/>
+          </a:p>
+        </p:txBody>
+      </p:sp>
+      <p:sp>
+        <p:nvSpPr>
+          <p:cNvPr id="225" name="Shape 203"/>
+          <p:cNvSpPr/>
+          <p:nvPr/>
+        </p:nvSpPr>
+        <p:spPr>
+          <a:xfrm>
+            <a:off x="2603297" y="2908706"/>
+            <a:ext cx="397764" cy="133502"/>
           </a:xfrm>
           <a:prstGeom prst="roundRect">
             <a:avLst>
-              <a:gd name="adj" fmla="val 21930"/>
+              <a:gd name="adj" fmla="val 30822"/>
             </a:avLst>
           </a:prstGeom>
           <a:solidFill>
@@ -27091,14 +27171,14 @@
       </p:sp>
       <p:sp>
         <p:nvSpPr>
-          <p:cNvPr id="222" name="Text 200"/>
-          <p:cNvSpPr/>
-          <p:nvPr/>
-        </p:nvSpPr>
-        <p:spPr>
-          <a:xfrm>
-            <a:off x="2609698" y="2880360"/>
-            <a:ext cx="384962" cy="190195"/>
+          <p:cNvPr id="226" name="Text 204"/>
+          <p:cNvSpPr/>
+          <p:nvPr/>
+        </p:nvSpPr>
+        <p:spPr>
+          <a:xfrm>
+            <a:off x="2621585" y="2914193"/>
+            <a:ext cx="361188" cy="122530"/>
           </a:xfrm>
           <a:prstGeom prst="rect">
             <a:avLst/>
@@ -27112,12 +27192,12 @@
           <a:p>
             <a:pPr algn="ctr" indent="0" marL="0">
               <a:lnSpc>
-                <a:spcPct val="102000"/>
+                <a:spcPct val="100000"/>
               </a:lnSpc>
               <a:buNone/>
             </a:pPr>
             <a:r>
-              <a:rPr lang="en-US" sz="410" b="1" dirty="0">
+              <a:rPr lang="en-US" sz="385" b="1" dirty="0">
                 <a:solidFill>
                   <a:srgbClr val="202124"/>
                 </a:solidFill>
@@ -27127,17 +27207,17 @@
               </a:rPr>
               <a:t>OBO + KMS</a:t>
             </a:r>
-            <a:endParaRPr lang="en-US" sz="410" dirty="0"/>
+            <a:endParaRPr lang="en-US" sz="385" dirty="0"/>
           </a:p>
           <a:p>
             <a:pPr algn="ctr" indent="0" marL="0">
               <a:lnSpc>
-                <a:spcPct val="102000"/>
+                <a:spcPct val="100000"/>
               </a:lnSpc>
               <a:buNone/>
             </a:pPr>
             <a:r>
-              <a:rPr lang="en-US" sz="375" dirty="0">
+              <a:rPr lang="en-US" sz="350" dirty="0">
                 <a:solidFill>
                   <a:srgbClr val="202124"/>
                 </a:solidFill>
@@ -27147,24 +27227,24 @@
               </a:rPr>
               <a:t>ECDSA sign</a:t>
             </a:r>
-            <a:endParaRPr lang="en-US" sz="410" dirty="0"/>
-          </a:p>
-        </p:txBody>
-      </p:sp>
-      <p:sp>
-        <p:nvSpPr>
-          <p:cNvPr id="223" name="Shape 201"/>
-          <p:cNvSpPr/>
-          <p:nvPr/>
-        </p:nvSpPr>
-        <p:spPr>
-          <a:xfrm>
-            <a:off x="1757477" y="4605833"/>
-            <a:ext cx="589788" cy="138989"/>
+            <a:endParaRPr lang="en-US" sz="385" dirty="0"/>
+          </a:p>
+        </p:txBody>
+      </p:sp>
+      <p:sp>
+        <p:nvSpPr>
+          <p:cNvPr id="227" name="Shape 205"/>
+          <p:cNvSpPr/>
+          <p:nvPr/>
+        </p:nvSpPr>
+        <p:spPr>
+          <a:xfrm>
+            <a:off x="1757477" y="4623206"/>
+            <a:ext cx="554126" cy="103327"/>
           </a:xfrm>
           <a:prstGeom prst="roundRect">
             <a:avLst>
-              <a:gd name="adj" fmla="val 32895"/>
+              <a:gd name="adj" fmla="val 39823"/>
             </a:avLst>
           </a:prstGeom>
           <a:solidFill>
@@ -27180,14 +27260,14 @@
       </p:sp>
       <p:sp>
         <p:nvSpPr>
-          <p:cNvPr id="224" name="Text 202"/>
-          <p:cNvSpPr/>
-          <p:nvPr/>
-        </p:nvSpPr>
-        <p:spPr>
-          <a:xfrm>
-            <a:off x="1777594" y="4614977"/>
-            <a:ext cx="549554" cy="120701"/>
+          <p:cNvPr id="228" name="Text 206"/>
+          <p:cNvSpPr/>
+          <p:nvPr/>
+        </p:nvSpPr>
+        <p:spPr>
+          <a:xfrm>
+            <a:off x="1775765" y="4628693"/>
+            <a:ext cx="517550" cy="92354"/>
           </a:xfrm>
           <a:prstGeom prst="rect">
             <a:avLst/>
@@ -27201,12 +27281,12 @@
           <a:p>
             <a:pPr algn="ctr" indent="0" marL="0">
               <a:lnSpc>
-                <a:spcPct val="102000"/>
+                <a:spcPct val="100000"/>
               </a:lnSpc>
               <a:buNone/>
             </a:pPr>
             <a:r>
-              <a:rPr lang="en-US" sz="410" b="1" dirty="0">
+              <a:rPr lang="en-US" sz="385" b="1" dirty="0">
                 <a:solidFill>
                   <a:srgbClr val="202124"/>
                 </a:solidFill>
@@ -27216,24 +27296,24 @@
               </a:rPr>
               <a:t>Sanitize request</a:t>
             </a:r>
-            <a:endParaRPr lang="en-US" sz="410" dirty="0"/>
-          </a:p>
-        </p:txBody>
-      </p:sp>
-      <p:sp>
-        <p:nvSpPr>
-          <p:cNvPr id="225" name="Shape 203"/>
-          <p:cNvSpPr/>
-          <p:nvPr/>
-        </p:nvSpPr>
-        <p:spPr>
-          <a:xfrm>
-            <a:off x="1757477" y="4814316"/>
-            <a:ext cx="617220" cy="138989"/>
+            <a:endParaRPr lang="en-US" sz="385" dirty="0"/>
+          </a:p>
+        </p:txBody>
+      </p:sp>
+      <p:sp>
+        <p:nvSpPr>
+          <p:cNvPr id="229" name="Shape 207"/>
+          <p:cNvSpPr/>
+          <p:nvPr/>
+        </p:nvSpPr>
+        <p:spPr>
+          <a:xfrm>
+            <a:off x="1757477" y="4831690"/>
+            <a:ext cx="580644" cy="103327"/>
           </a:xfrm>
           <a:prstGeom prst="roundRect">
             <a:avLst>
-              <a:gd name="adj" fmla="val 32895"/>
+              <a:gd name="adj" fmla="val 39823"/>
             </a:avLst>
           </a:prstGeom>
           <a:solidFill>
@@ -27249,14 +27329,14 @@
       </p:sp>
       <p:sp>
         <p:nvSpPr>
-          <p:cNvPr id="226" name="Text 204"/>
-          <p:cNvSpPr/>
-          <p:nvPr/>
-        </p:nvSpPr>
-        <p:spPr>
-          <a:xfrm>
-            <a:off x="1777594" y="4823460"/>
-            <a:ext cx="576986" cy="120701"/>
+          <p:cNvPr id="230" name="Text 208"/>
+          <p:cNvSpPr/>
+          <p:nvPr/>
+        </p:nvSpPr>
+        <p:spPr>
+          <a:xfrm>
+            <a:off x="1775765" y="4837176"/>
+            <a:ext cx="544068" cy="92354"/>
           </a:xfrm>
           <a:prstGeom prst="rect">
             <a:avLst/>
@@ -27270,12 +27350,12 @@
           <a:p>
             <a:pPr algn="ctr" indent="0" marL="0">
               <a:lnSpc>
-                <a:spcPct val="102000"/>
+                <a:spcPct val="100000"/>
               </a:lnSpc>
               <a:buNone/>
             </a:pPr>
             <a:r>
-              <a:rPr lang="en-US" sz="410" b="1" dirty="0">
+              <a:rPr lang="en-US" sz="385" b="1" dirty="0">
                 <a:solidFill>
                   <a:srgbClr val="202124"/>
                 </a:solidFill>
@@ -27285,24 +27365,24 @@
               </a:rPr>
               <a:t>Sanitize response</a:t>
             </a:r>
-            <a:endParaRPr lang="en-US" sz="410" dirty="0"/>
-          </a:p>
-        </p:txBody>
-      </p:sp>
-      <p:sp>
-        <p:nvSpPr>
-          <p:cNvPr id="227" name="Shape 205"/>
-          <p:cNvSpPr/>
-          <p:nvPr/>
-        </p:nvSpPr>
-        <p:spPr>
-          <a:xfrm>
-            <a:off x="2443277" y="2080260"/>
-            <a:ext cx="480060" cy="208483"/>
+            <a:endParaRPr lang="en-US" sz="385" dirty="0"/>
+          </a:p>
+        </p:txBody>
+      </p:sp>
+      <p:sp>
+        <p:nvSpPr>
+          <p:cNvPr id="231" name="Shape 209"/>
+          <p:cNvSpPr/>
+          <p:nvPr/>
+        </p:nvSpPr>
+        <p:spPr>
+          <a:xfrm>
+            <a:off x="2458822" y="2117750"/>
+            <a:ext cx="449885" cy="133502"/>
           </a:xfrm>
           <a:prstGeom prst="roundRect">
             <a:avLst>
-              <a:gd name="adj" fmla="val 21930"/>
+              <a:gd name="adj" fmla="val 30822"/>
             </a:avLst>
           </a:prstGeom>
           <a:solidFill>
@@ -27318,14 +27398,14 @@
       </p:sp>
       <p:sp>
         <p:nvSpPr>
-          <p:cNvPr id="228" name="Text 206"/>
-          <p:cNvSpPr/>
-          <p:nvPr/>
-        </p:nvSpPr>
-        <p:spPr>
-          <a:xfrm>
-            <a:off x="2463394" y="2089404"/>
-            <a:ext cx="439826" cy="190195"/>
+          <p:cNvPr id="232" name="Text 210"/>
+          <p:cNvSpPr/>
+          <p:nvPr/>
+        </p:nvSpPr>
+        <p:spPr>
+          <a:xfrm>
+            <a:off x="2477110" y="2123237"/>
+            <a:ext cx="413309" cy="122530"/>
           </a:xfrm>
           <a:prstGeom prst="rect">
             <a:avLst/>
@@ -27339,12 +27419,12 @@
           <a:p>
             <a:pPr algn="ctr" indent="0" marL="0">
               <a:lnSpc>
-                <a:spcPct val="102000"/>
+                <a:spcPct val="100000"/>
               </a:lnSpc>
               <a:buNone/>
             </a:pPr>
             <a:r>
-              <a:rPr lang="en-US" sz="410" b="1" dirty="0">
+              <a:rPr lang="en-US" sz="385" b="1" dirty="0">
                 <a:solidFill>
                   <a:srgbClr val="202124"/>
                 </a:solidFill>
@@ -27354,17 +27434,17 @@
               </a:rPr>
               <a:t>Header &amp; WAF</a:t>
             </a:r>
-            <a:endParaRPr lang="en-US" sz="410" dirty="0"/>
+            <a:endParaRPr lang="en-US" sz="385" dirty="0"/>
           </a:p>
           <a:p>
             <a:pPr algn="ctr" indent="0" marL="0">
               <a:lnSpc>
-                <a:spcPct val="102000"/>
+                <a:spcPct val="100000"/>
               </a:lnSpc>
               <a:buNone/>
             </a:pPr>
             <a:r>
-              <a:rPr lang="en-US" sz="375" dirty="0">
+              <a:rPr lang="en-US" sz="350" dirty="0">
                 <a:solidFill>
                   <a:srgbClr val="202124"/>
                 </a:solidFill>
@@ -27374,24 +27454,24 @@
               </a:rPr>
               <a:t>policies</a:t>
             </a:r>
-            <a:endParaRPr lang="en-US" sz="410" dirty="0"/>
-          </a:p>
-        </p:txBody>
-      </p:sp>
-      <p:sp>
-        <p:nvSpPr>
-          <p:cNvPr id="229" name="Shape 207"/>
-          <p:cNvSpPr/>
-          <p:nvPr/>
-        </p:nvSpPr>
-        <p:spPr>
-          <a:xfrm>
-            <a:off x="2498141" y="2625242"/>
-            <a:ext cx="370332" cy="208483"/>
+            <a:endParaRPr lang="en-US" sz="385" dirty="0"/>
+          </a:p>
+        </p:txBody>
+      </p:sp>
+      <p:sp>
+        <p:nvSpPr>
+          <p:cNvPr id="233" name="Shape 211"/>
+          <p:cNvSpPr/>
+          <p:nvPr/>
+        </p:nvSpPr>
+        <p:spPr>
+          <a:xfrm>
+            <a:off x="2510942" y="2717597"/>
+            <a:ext cx="345643" cy="133502"/>
           </a:xfrm>
           <a:prstGeom prst="roundRect">
             <a:avLst>
-              <a:gd name="adj" fmla="val 21930"/>
+              <a:gd name="adj" fmla="val 30822"/>
             </a:avLst>
           </a:prstGeom>
           <a:solidFill>
@@ -27407,14 +27487,14 @@
       </p:sp>
       <p:sp>
         <p:nvSpPr>
-          <p:cNvPr id="230" name="Text 208"/>
-          <p:cNvSpPr/>
-          <p:nvPr/>
-        </p:nvSpPr>
-        <p:spPr>
-          <a:xfrm>
-            <a:off x="2518258" y="2634386"/>
-            <a:ext cx="330098" cy="190195"/>
+          <p:cNvPr id="234" name="Text 212"/>
+          <p:cNvSpPr/>
+          <p:nvPr/>
+        </p:nvSpPr>
+        <p:spPr>
+          <a:xfrm>
+            <a:off x="2529230" y="2723083"/>
+            <a:ext cx="309067" cy="122530"/>
           </a:xfrm>
           <a:prstGeom prst="rect">
             <a:avLst/>
@@ -27428,12 +27508,12 @@
           <a:p>
             <a:pPr algn="ctr" indent="0" marL="0">
               <a:lnSpc>
-                <a:spcPct val="102000"/>
+                <a:spcPct val="100000"/>
               </a:lnSpc>
               <a:buNone/>
             </a:pPr>
             <a:r>
-              <a:rPr lang="en-US" sz="410" b="1" dirty="0">
+              <a:rPr lang="en-US" sz="385" b="1" dirty="0">
                 <a:solidFill>
                   <a:srgbClr val="202124"/>
                 </a:solidFill>
@@ -27443,17 +27523,17 @@
               </a:rPr>
               <a:t>Sanitize</a:t>
             </a:r>
-            <a:endParaRPr lang="en-US" sz="410" dirty="0"/>
+            <a:endParaRPr lang="en-US" sz="385" dirty="0"/>
           </a:p>
           <a:p>
             <a:pPr algn="ctr" indent="0" marL="0">
               <a:lnSpc>
-                <a:spcPct val="102000"/>
+                <a:spcPct val="100000"/>
               </a:lnSpc>
               <a:buNone/>
             </a:pPr>
             <a:r>
-              <a:rPr lang="en-US" sz="375" dirty="0">
+              <a:rPr lang="en-US" sz="350" dirty="0">
                 <a:solidFill>
                   <a:srgbClr val="202124"/>
                 </a:solidFill>
@@ -27463,24 +27543,24 @@
               </a:rPr>
               <a:t>prompt</a:t>
             </a:r>
-            <a:endParaRPr lang="en-US" sz="410" dirty="0"/>
-          </a:p>
-        </p:txBody>
-      </p:sp>
-      <p:sp>
-        <p:nvSpPr>
-          <p:cNvPr id="231" name="Shape 209"/>
-          <p:cNvSpPr/>
-          <p:nvPr/>
-        </p:nvSpPr>
-        <p:spPr>
-          <a:xfrm>
-            <a:off x="3888029" y="1144829"/>
-            <a:ext cx="370332" cy="138989"/>
+            <a:endParaRPr lang="en-US" sz="385" dirty="0"/>
+          </a:p>
+        </p:txBody>
+      </p:sp>
+      <p:sp>
+        <p:nvSpPr>
+          <p:cNvPr id="235" name="Shape 213"/>
+          <p:cNvSpPr/>
+          <p:nvPr/>
+        </p:nvSpPr>
+        <p:spPr>
+          <a:xfrm>
+            <a:off x="3888029" y="1163117"/>
+            <a:ext cx="345643" cy="103327"/>
           </a:xfrm>
           <a:prstGeom prst="roundRect">
             <a:avLst>
-              <a:gd name="adj" fmla="val 32895"/>
+              <a:gd name="adj" fmla="val 39823"/>
             </a:avLst>
           </a:prstGeom>
           <a:solidFill>
@@ -27496,14 +27576,14 @@
       </p:sp>
       <p:sp>
         <p:nvSpPr>
-          <p:cNvPr id="232" name="Text 210"/>
-          <p:cNvSpPr/>
-          <p:nvPr/>
-        </p:nvSpPr>
-        <p:spPr>
-          <a:xfrm>
-            <a:off x="3908146" y="1153973"/>
-            <a:ext cx="330098" cy="120701"/>
+          <p:cNvPr id="236" name="Text 214"/>
+          <p:cNvSpPr/>
+          <p:nvPr/>
+        </p:nvSpPr>
+        <p:spPr>
+          <a:xfrm>
+            <a:off x="3906317" y="1168603"/>
+            <a:ext cx="309067" cy="92354"/>
           </a:xfrm>
           <a:prstGeom prst="rect">
             <a:avLst/>
@@ -27517,12 +27597,12 @@
           <a:p>
             <a:pPr algn="ctr" indent="0" marL="0">
               <a:lnSpc>
-                <a:spcPct val="102000"/>
+                <a:spcPct val="100000"/>
               </a:lnSpc>
               <a:buNone/>
             </a:pPr>
             <a:r>
-              <a:rPr lang="en-US" sz="410" b="1" dirty="0">
+              <a:rPr lang="en-US" sz="385" b="1" dirty="0">
                 <a:solidFill>
                   <a:srgbClr val="202124"/>
                 </a:solidFill>
@@ -27532,24 +27612,24 @@
               </a:rPr>
               <a:t>Response</a:t>
             </a:r>
-            <a:endParaRPr lang="en-US" sz="410" dirty="0"/>
-          </a:p>
-        </p:txBody>
-      </p:sp>
-      <p:sp>
-        <p:nvSpPr>
-          <p:cNvPr id="233" name="Shape 211"/>
-          <p:cNvSpPr/>
-          <p:nvPr/>
-        </p:nvSpPr>
-        <p:spPr>
-          <a:xfrm>
-            <a:off x="3888029" y="2723083"/>
-            <a:ext cx="370332" cy="138989"/>
+            <a:endParaRPr lang="en-US" sz="385" dirty="0"/>
+          </a:p>
+        </p:txBody>
+      </p:sp>
+      <p:sp>
+        <p:nvSpPr>
+          <p:cNvPr id="237" name="Shape 215"/>
+          <p:cNvSpPr/>
+          <p:nvPr/>
+        </p:nvSpPr>
+        <p:spPr>
+          <a:xfrm>
+            <a:off x="3888029" y="2740457"/>
+            <a:ext cx="345643" cy="103327"/>
           </a:xfrm>
           <a:prstGeom prst="roundRect">
             <a:avLst>
-              <a:gd name="adj" fmla="val 32895"/>
+              <a:gd name="adj" fmla="val 39823"/>
             </a:avLst>
           </a:prstGeom>
           <a:solidFill>
@@ -27565,14 +27645,14 @@
       </p:sp>
       <p:sp>
         <p:nvSpPr>
-          <p:cNvPr id="234" name="Text 212"/>
-          <p:cNvSpPr/>
-          <p:nvPr/>
-        </p:nvSpPr>
-        <p:spPr>
-          <a:xfrm>
-            <a:off x="3908146" y="2732227"/>
-            <a:ext cx="330098" cy="120701"/>
+          <p:cNvPr id="238" name="Text 216"/>
+          <p:cNvSpPr/>
+          <p:nvPr/>
+        </p:nvSpPr>
+        <p:spPr>
+          <a:xfrm>
+            <a:off x="3906317" y="2745943"/>
+            <a:ext cx="309067" cy="92354"/>
           </a:xfrm>
           <a:prstGeom prst="rect">
             <a:avLst/>
@@ -27586,12 +27666,12 @@
           <a:p>
             <a:pPr algn="ctr" indent="0" marL="0">
               <a:lnSpc>
-                <a:spcPct val="102000"/>
+                <a:spcPct val="100000"/>
               </a:lnSpc>
               <a:buNone/>
             </a:pPr>
             <a:r>
-              <a:rPr lang="en-US" sz="410" b="1" dirty="0">
+              <a:rPr lang="en-US" sz="385" b="1" dirty="0">
                 <a:solidFill>
                   <a:srgbClr val="202124"/>
                 </a:solidFill>
@@ -27601,24 +27681,24 @@
               </a:rPr>
               <a:t>Response</a:t>
             </a:r>
-            <a:endParaRPr lang="en-US" sz="410" dirty="0"/>
-          </a:p>
-        </p:txBody>
-      </p:sp>
-      <p:sp>
-        <p:nvSpPr>
-          <p:cNvPr id="235" name="Shape 213"/>
-          <p:cNvSpPr/>
-          <p:nvPr/>
-        </p:nvSpPr>
-        <p:spPr>
-          <a:xfrm>
-            <a:off x="3144622" y="1144829"/>
-            <a:ext cx="342900" cy="138989"/>
+            <a:endParaRPr lang="en-US" sz="385" dirty="0"/>
+          </a:p>
+        </p:txBody>
+      </p:sp>
+      <p:sp>
+        <p:nvSpPr>
+          <p:cNvPr id="239" name="Shape 217"/>
+          <p:cNvSpPr/>
+          <p:nvPr/>
+        </p:nvSpPr>
+        <p:spPr>
+          <a:xfrm>
+            <a:off x="3167482" y="1163117"/>
+            <a:ext cx="320040" cy="103327"/>
           </a:xfrm>
           <a:prstGeom prst="roundRect">
             <a:avLst>
-              <a:gd name="adj" fmla="val 32895"/>
+              <a:gd name="adj" fmla="val 39823"/>
             </a:avLst>
           </a:prstGeom>
           <a:solidFill>
@@ -27634,14 +27714,14 @@
       </p:sp>
       <p:sp>
         <p:nvSpPr>
-          <p:cNvPr id="236" name="Text 214"/>
-          <p:cNvSpPr/>
-          <p:nvPr/>
-        </p:nvSpPr>
-        <p:spPr>
-          <a:xfrm>
-            <a:off x="3164738" y="1153973"/>
-            <a:ext cx="302666" cy="120701"/>
+          <p:cNvPr id="240" name="Text 218"/>
+          <p:cNvSpPr/>
+          <p:nvPr/>
+        </p:nvSpPr>
+        <p:spPr>
+          <a:xfrm>
+            <a:off x="3185770" y="1168603"/>
+            <a:ext cx="283464" cy="92354"/>
           </a:xfrm>
           <a:prstGeom prst="rect">
             <a:avLst/>
@@ -27655,12 +27735,12 @@
           <a:p>
             <a:pPr algn="ctr" indent="0" marL="0">
               <a:lnSpc>
-                <a:spcPct val="102000"/>
+                <a:spcPct val="100000"/>
               </a:lnSpc>
               <a:buNone/>
             </a:pPr>
             <a:r>
-              <a:rPr lang="en-US" sz="410" b="1" dirty="0">
+              <a:rPr lang="en-US" sz="385" b="1" dirty="0">
                 <a:solidFill>
                   <a:srgbClr val="202124"/>
                 </a:solidFill>
@@ -27670,24 +27750,24 @@
               </a:rPr>
               <a:t>Request</a:t>
             </a:r>
-            <a:endParaRPr lang="en-US" sz="410" dirty="0"/>
-          </a:p>
-        </p:txBody>
-      </p:sp>
-      <p:sp>
-        <p:nvSpPr>
-          <p:cNvPr id="237" name="Shape 215"/>
-          <p:cNvSpPr/>
-          <p:nvPr/>
-        </p:nvSpPr>
-        <p:spPr>
-          <a:xfrm>
-            <a:off x="3144622" y="2723083"/>
-            <a:ext cx="342900" cy="138989"/>
+            <a:endParaRPr lang="en-US" sz="385" dirty="0"/>
+          </a:p>
+        </p:txBody>
+      </p:sp>
+      <p:sp>
+        <p:nvSpPr>
+          <p:cNvPr id="241" name="Shape 219"/>
+          <p:cNvSpPr/>
+          <p:nvPr/>
+        </p:nvSpPr>
+        <p:spPr>
+          <a:xfrm>
+            <a:off x="3167482" y="2740457"/>
+            <a:ext cx="320040" cy="103327"/>
           </a:xfrm>
           <a:prstGeom prst="roundRect">
             <a:avLst>
-              <a:gd name="adj" fmla="val 32895"/>
+              <a:gd name="adj" fmla="val 39823"/>
             </a:avLst>
           </a:prstGeom>
           <a:solidFill>
@@ -27703,14 +27783,14 @@
       </p:sp>
       <p:sp>
         <p:nvSpPr>
-          <p:cNvPr id="238" name="Text 216"/>
-          <p:cNvSpPr/>
-          <p:nvPr/>
-        </p:nvSpPr>
-        <p:spPr>
-          <a:xfrm>
-            <a:off x="3164738" y="2732227"/>
-            <a:ext cx="302666" cy="120701"/>
+          <p:cNvPr id="242" name="Text 220"/>
+          <p:cNvSpPr/>
+          <p:nvPr/>
+        </p:nvSpPr>
+        <p:spPr>
+          <a:xfrm>
+            <a:off x="3185770" y="2745943"/>
+            <a:ext cx="283464" cy="92354"/>
           </a:xfrm>
           <a:prstGeom prst="rect">
             <a:avLst/>
@@ -27724,12 +27804,12 @@
           <a:p>
             <a:pPr algn="ctr" indent="0" marL="0">
               <a:lnSpc>
-                <a:spcPct val="102000"/>
+                <a:spcPct val="100000"/>
               </a:lnSpc>
               <a:buNone/>
             </a:pPr>
             <a:r>
-              <a:rPr lang="en-US" sz="410" b="1" dirty="0">
+              <a:rPr lang="en-US" sz="385" b="1" dirty="0">
                 <a:solidFill>
                   <a:srgbClr val="202124"/>
                 </a:solidFill>
@@ -27739,13 +27819,13 @@
               </a:rPr>
               <a:t>Request</a:t>
             </a:r>
-            <a:endParaRPr lang="en-US" sz="410" dirty="0"/>
-          </a:p>
-        </p:txBody>
-      </p:sp>
-      <p:sp>
-        <p:nvSpPr>
-          <p:cNvPr id="239" name="Text 217"/>
+            <a:endParaRPr lang="en-US" sz="385" dirty="0"/>
+          </a:p>
+        </p:txBody>
+      </p:sp>
+      <p:sp>
+        <p:nvSpPr>
+          <p:cNvPr id="243" name="Text 221"/>
           <p:cNvSpPr/>
           <p:nvPr/>
         </p:nvSpPr>

</xml_diff>

<commit_message>
fix(ws1): align Slide 1 and Slide 15 internal slide-number cross-references to 15-slide layout
</commit_message>
<xml_diff>
--- a/slides/ws1-google-slides-design-plugin-editable-slides.pptx
+++ b/slides/ws1-google-slides-design-plugin-editable-slides.pptx
@@ -3602,7 +3602,7 @@
                 <a:ea typeface="Google Sans" pitchFamily="34" charset="-122"/>
                 <a:cs typeface="Google Sans" pitchFamily="34" charset="-120"/>
               </a:rPr>
-              <a:t>Agenda, Personas &amp; 12-Dim Pattern Matrix</a:t>
+              <a:t>Problem, Personas &amp; Conceptual Model</a:t>
             </a:r>
             <a:endParaRPr lang="en-US" sz="850" dirty="0"/>
           </a:p>
@@ -3641,7 +3641,7 @@
                 <a:ea typeface="Roboto" pitchFamily="34" charset="-122"/>
                 <a:cs typeface="Roboto" pitchFamily="34" charset="-120"/>
               </a:rPr>
-              <a:t>Maps ADK/MCP/ARD to CS101 OS primitives; sets the 5-Act agenda (Slide 2), contrasts FinVault (600 RPM: Dedicated PT vs. GKE Gemma 3) &amp; RetailStream (120 RPM: 3LO vault, Slide 3), and compares Patterns A/B/C (Slide 4).</a:t>
+              <a:t>Maps ADK/MCP/ARD to CS101 OS primitives; sets the 5-Part agenda (Slide 2), contrasts FinVault &amp; RetailStream (Slide 3), and decouples the 80% 5-Hop Core from 20% Perimeter Delta (Slide 4).</a:t>
             </a:r>
             <a:endParaRPr lang="en-US" sz="780" dirty="0"/>
           </a:p>
@@ -3749,7 +3749,7 @@
                 <a:ea typeface="Google Sans" pitchFamily="34" charset="-122"/>
                 <a:cs typeface="Google Sans" pitchFamily="34" charset="-120"/>
               </a:rPr>
-              <a:t>PART 2 • SLIDES 5–6 &amp; 8</a:t>
+              <a:t>PART 2 • SLIDES 5–9</a:t>
             </a:r>
             <a:endParaRPr lang="en-US" sz="660" dirty="0"/>
           </a:p>
@@ -3788,7 +3788,7 @@
                 <a:ea typeface="Google Sans" pitchFamily="34" charset="-122"/>
                 <a:cs typeface="Google Sans" pitchFamily="34" charset="-120"/>
               </a:rPr>
-              <a:t>L1 3 Layers → L2 4 Perimeters → L4 Wire</a:t>
+              <a:t>Process Flow, L1 Layers, Matrix &amp; L2 Figures</a:t>
             </a:r>
             <a:endParaRPr lang="en-US" sz="850" dirty="0"/>
           </a:p>
@@ -3827,7 +3827,7 @@
                 <a:ea typeface="Roboto" pitchFamily="34" charset="-122"/>
                 <a:cs typeface="Roboto" pitchFamily="34" charset="-120"/>
               </a:rPr>
-              <a:t>Zooms macro-to-micro from the 3 Logical Security Layers (~42ms p95, Slide 5) into the 4 Physical VPC-SC Perimeters &amp; Steps 1–7 in Figure 1 (Slide 6) and &lt;0.15ms cached-JWKS STS JWT wire packet (Slide 8).</a:t>
+              <a:t>Traces the ~42ms p95 6-stage lifecycle (Slide 5), L1 3 Security Layers (Slide 6), 12-Dim Pattern A/B/C Matrix (Slide 7), and L2 Physical Figures 1 &amp; 2 (Slides 8–9).</a:t>
             </a:r>
             <a:endParaRPr lang="en-US" sz="780" dirty="0"/>
           </a:p>
@@ -3935,7 +3935,7 @@
                 <a:ea typeface="Google Sans" pitchFamily="34" charset="-122"/>
                 <a:cs typeface="Google Sans" pitchFamily="34" charset="-120"/>
               </a:rPr>
-              <a:t>PART 3 • SLIDE 7 (L3)</a:t>
+              <a:t>PART 3 • SLIDES 10–12</a:t>
             </a:r>
             <a:endParaRPr lang="en-US" sz="660" dirty="0"/>
           </a:p>
@@ -3974,7 +3974,7 @@
                 <a:ea typeface="Google Sans" pitchFamily="34" charset="-122"/>
                 <a:cs typeface="Google Sans" pitchFamily="34" charset="-120"/>
               </a:rPr>
-              <a:t>Merged L3 UML, Breakers &amp; Stampede Lock</a:t>
+              <a:t>L3 UML, L4 Wire JWT &amp; GAP-01..05 Controls</a:t>
             </a:r>
             <a:endParaRPr lang="en-US" sz="850" dirty="0"/>
           </a:p>
@@ -4013,7 +4013,7 @@
                 <a:ea typeface="Roboto" pitchFamily="34" charset="-122"/>
                 <a:cs typeface="Roboto" pitchFamily="34" charset="-120"/>
               </a:rPr>
-              <a:t>Unifies the 5-Actor chronological UML sequence (Hops 1–5 / UML Steps 1–6) with [Alt] fail-closed circuit breakers (HTTP 401–429), &lt;5s targeted Valkey SCAN+UNLINK, and SET NX PX 5000 single-flight recovery (Slide 7).</a:t>
+              <a:t>Unifies the 5-Actor UML sequence &amp; &lt;5s Valkey eviction (Slide 10), &lt;0.15ms cached-JWKS STS JWT wire packet (Slide 11), and feature-flagged GAP-01..05 sunset hooks (Slide 12).</a:t>
             </a:r>
             <a:endParaRPr lang="en-US" sz="780" dirty="0"/>
           </a:p>
@@ -4121,7 +4121,7 @@
                 <a:ea typeface="Google Sans" pitchFamily="34" charset="-122"/>
                 <a:cs typeface="Google Sans" pitchFamily="34" charset="-120"/>
               </a:rPr>
-              <a:t>PARTS 4–5 • SLIDES 9–11</a:t>
+              <a:t>PARTS 4–5 • SLIDES 13–15</a:t>
             </a:r>
             <a:endParaRPr lang="en-US" sz="660" dirty="0"/>
           </a:p>
@@ -4160,7 +4160,7 @@
                 <a:ea typeface="Google Sans" pitchFamily="34" charset="-122"/>
                 <a:cs typeface="Google Sans" pitchFamily="34" charset="-120"/>
               </a:rPr>
-              <a:t>GAP-01..05, Live GCP Proof &amp; Merged SLAs</a:t>
+              <a:t>Dual-Plane Proofs, Retina UIs &amp; SLAs</a:t>
             </a:r>
             <a:endParaRPr lang="en-US" sz="850" dirty="0"/>
           </a:p>
@@ -4199,7 +4199,7 @@
                 <a:ea typeface="Roboto" pitchFamily="34" charset="-122"/>
                 <a:cs typeface="Roboto" pitchFamily="34" charset="-120"/>
               </a:rPr>
-              <a:t>Details feature-flagged GAP-01..05 sunset hooks + BigQuery OTel SQL (Slide 9), live Cloud Run &amp; Cloud Logging proof (Slide 10), and merged Well-Architected SLAs + 5 runnable GitHub milestones (Slide 11).</a:t>
+              <a:t>Presents grounded GCP/AWS CLI telemetry (Slide 13), live 2880x1800 Retina Before/After 3P SaaS UIs (Slide 14), and Well-Architected SLAs + 5 GitHub milestones (Slide 15).</a:t>
             </a:r>
             <a:endParaRPr lang="en-US" sz="780" dirty="0"/>
           </a:p>
@@ -16220,7 +16220,7 @@
                 <a:ea typeface="Google Sans" pitchFamily="34" charset="-122"/>
                 <a:cs typeface="Google Sans" pitchFamily="34" charset="-120"/>
               </a:rPr>
-              <a:t>Part 2 (Slides 5, 6 &amp; 8) — 5-Hop Pipeline &amp; Pattern A Pool</a:t>
+              <a:t>Part 2 (Slides 5–9) — 5-Hop Pipeline &amp; Pattern A Pool</a:t>
             </a:r>
             <a:endParaRPr lang="en-US" sz="1040" dirty="0"/>
           </a:p>
@@ -16441,7 +16441,7 @@
                 <a:ea typeface="Google Sans" pitchFamily="34" charset="-122"/>
                 <a:cs typeface="Google Sans" pitchFamily="34" charset="-120"/>
               </a:rPr>
-              <a:t>Owner: Cloud Security &amp; IAM  •  Part 2: 5-Hop &amp; Pattern A</a:t>
+              <a:t>Owner: Cloud Security &amp; IAM  •  Part 2: 5-Hop &amp; Pattern A (Slides 5–9)</a:t>
             </a:r>
             <a:endParaRPr lang="en-US" sz="750" dirty="0"/>
           </a:p>
@@ -16588,7 +16588,7 @@
                 <a:ea typeface="Google Sans" pitchFamily="34" charset="-122"/>
                 <a:cs typeface="Google Sans" pitchFamily="34" charset="-120"/>
               </a:rPr>
-              <a:t>Part 3 (Slide 7) — Circuit Breakers, CMEK &amp; Valkey L1 Flush</a:t>
+              <a:t>Part 3 (Slide 10) — Circuit Breakers, CMEK &amp; Valkey L1 Flush</a:t>
             </a:r>
             <a:endParaRPr lang="en-US" sz="1040" dirty="0"/>
           </a:p>
@@ -16809,7 +16809,7 @@
                 <a:ea typeface="Google Sans" pitchFamily="34" charset="-122"/>
                 <a:cs typeface="Google Sans" pitchFamily="34" charset="-120"/>
               </a:rPr>
-              <a:t>Owner: Data &amp; FinOps SRE  •  Part 3: Breakers &amp; Silos (Slide 7)</a:t>
+              <a:t>Owner: Data &amp; FinOps SRE  •  Part 3: Breakers &amp; Silos (Slide 10)</a:t>
             </a:r>
             <a:endParaRPr lang="en-US" sz="750" dirty="0"/>
           </a:p>
@@ -16956,7 +16956,7 @@
                 <a:ea typeface="Google Sans" pitchFamily="34" charset="-122"/>
                 <a:cs typeface="Google Sans" pitchFamily="34" charset="-120"/>
               </a:rPr>
-              <a:t>Part 4 (Slide 9) — EAP Gap Controls &amp; Pattern C Hybrid FinOps</a:t>
+              <a:t>Part 4 (Slides 11–12) — EAP Gap Controls &amp; Pattern C Hybrid FinOps</a:t>
             </a:r>
             <a:endParaRPr lang="en-US" sz="1140" dirty="0"/>
           </a:p>
@@ -17177,7 +17177,7 @@
                 <a:ea typeface="Google Sans" pitchFamily="34" charset="-122"/>
                 <a:cs typeface="Google Sans" pitchFamily="34" charset="-120"/>
               </a:rPr>
-              <a:t>Owner: Tenant Onboarding  •  Part 4: Gaps &amp; Hybrid PSC (Slide 9)</a:t>
+              <a:t>Owner: Tenant Onboarding  •  Part 4: Gaps &amp; Hybrid PSC (Slides 11–12)</a:t>
             </a:r>
             <a:endParaRPr lang="en-US" sz="750" dirty="0"/>
           </a:p>
@@ -17324,7 +17324,7 @@
                 <a:ea typeface="Google Sans" pitchFamily="34" charset="-122"/>
                 <a:cs typeface="Google Sans" pitchFamily="34" charset="-120"/>
               </a:rPr>
-              <a:t>Part 5 (Slides 10–11) — Dual-Plane CI/CD Forensic Audit &amp; Day-2 Operations</a:t>
+              <a:t>Part 5 (Slides 13–15) — Dual-Plane CI/CD Forensic Audit &amp; Day-2 Operations</a:t>
             </a:r>
             <a:endParaRPr lang="en-US" sz="1140" dirty="0"/>
           </a:p>
@@ -17545,7 +17545,7 @@
                 <a:ea typeface="Google Sans" pitchFamily="34" charset="-122"/>
                 <a:cs typeface="Google Sans" pitchFamily="34" charset="-120"/>
               </a:rPr>
-              <a:t>Owner: Governance &amp; CISO  •  Part 5: Dual-Plane CI/CD Gate (Slides 10–11)</a:t>
+              <a:t>Owner: Governance &amp; CISO  •  Part 5: Dual-Plane CI/CD Gate (Slides 13–15)</a:t>
             </a:r>
             <a:endParaRPr lang="en-US" sz="750" dirty="0"/>
           </a:p>
@@ -18219,7 +18219,7 @@
                 <a:ea typeface="Google Sans" pitchFamily="34" charset="-122"/>
                 <a:cs typeface="Google Sans" pitchFamily="34" charset="-120"/>
               </a:rPr>
-              <a:t>Agenda &amp; 5-Part Series Navigation — Streamlined 11-Slide Architecture Roadmap</a:t>
+              <a:t>Agenda &amp; 5-Part Series Navigation — 15-Slide Architecture Roadmap</a:t>
             </a:r>
             <a:endParaRPr lang="en-US" sz="1800" dirty="0"/>
           </a:p>
@@ -18605,7 +18605,7 @@
                           <a:ea typeface="Google Sans" pitchFamily="34" charset="-122"/>
                           <a:cs typeface="Google Sans" pitchFamily="34" charset="-120"/>
                         </a:rPr>
-                        <a:t>Isolation Topologies</a:t>
+                        <a:t>Isolation Topologies &amp; Concepts</a:t>
                       </a:r>
                       <a:endParaRPr lang="en-US" sz="900" dirty="0">
                         <a:latin typeface="Google Sans" charset="0"/>
@@ -18879,7 +18879,7 @@
                           <a:ea typeface="Google Sans" pitchFamily="34" charset="-122"/>
                           <a:cs typeface="Google Sans" pitchFamily="34" charset="-120"/>
                         </a:rPr>
-                        <a:t>Part 2 • Slides 5, 6 &amp; 8</a:t>
+                        <a:t>Part 2 • Slides 5–9</a:t>
                       </a:r>
                       <a:endParaRPr lang="en-US" sz="900" dirty="0">
                         <a:latin typeface="Google Sans" charset="0"/>
@@ -18900,7 +18900,7 @@
                           <a:ea typeface="Google Sans" pitchFamily="34" charset="-122"/>
                           <a:cs typeface="Google Sans" pitchFamily="34" charset="-120"/>
                         </a:rPr>
-                        <a:t>5-Hop Pipeline (L1/L2/L4)</a:t>
+                        <a:t>5-Hop Lifecycle &amp; L1/L2 Blueprints</a:t>
                       </a:r>
                       <a:endParaRPr lang="en-US" sz="900" dirty="0">
                         <a:latin typeface="Google Sans" charset="0"/>
@@ -19174,7 +19174,7 @@
                           <a:ea typeface="Google Sans" pitchFamily="34" charset="-122"/>
                           <a:cs typeface="Google Sans" pitchFamily="34" charset="-120"/>
                         </a:rPr>
-                        <a:t>Part 3 • Slide 7</a:t>
+                        <a:t>Part 3 • Slide 10</a:t>
                       </a:r>
                       <a:endParaRPr lang="en-US" sz="900" dirty="0">
                         <a:latin typeface="Google Sans" charset="0"/>
@@ -19469,7 +19469,7 @@
                           <a:ea typeface="Google Sans" pitchFamily="34" charset="-122"/>
                           <a:cs typeface="Google Sans" pitchFamily="34" charset="-120"/>
                         </a:rPr>
-                        <a:t>Part 4 • Slide 9</a:t>
+                        <a:t>Part 4 • Slides 11–12</a:t>
                       </a:r>
                       <a:endParaRPr lang="en-US" sz="900" dirty="0">
                         <a:latin typeface="Google Sans" charset="0"/>
@@ -19490,7 +19490,7 @@
                           <a:ea typeface="Google Sans" pitchFamily="34" charset="-122"/>
                           <a:cs typeface="Google Sans" pitchFamily="34" charset="-120"/>
                         </a:rPr>
-                        <a:t>Mind the Gap (GAP-01..05)</a:t>
+                        <a:t>L4 Wire Protocol &amp; EAP Gap Controls</a:t>
                       </a:r>
                       <a:endParaRPr lang="en-US" sz="900" dirty="0">
                         <a:latin typeface="Google Sans" charset="0"/>
@@ -19764,7 +19764,7 @@
                           <a:ea typeface="Google Sans" pitchFamily="34" charset="-122"/>
                           <a:cs typeface="Google Sans" pitchFamily="34" charset="-120"/>
                         </a:rPr>
-                        <a:t>Part 5 • Slides 10–11</a:t>
+                        <a:t>Part 5 • Slides 13–15</a:t>
                       </a:r>
                       <a:endParaRPr lang="en-US" sz="900" dirty="0">
                         <a:latin typeface="Google Sans" charset="0"/>
@@ -19785,7 +19785,7 @@
                           <a:ea typeface="Google Sans" pitchFamily="34" charset="-122"/>
                           <a:cs typeface="Google Sans" pitchFamily="34" charset="-120"/>
                         </a:rPr>
-                        <a:t>CI/CD Audit &amp; SLAs</a:t>
+                        <a:t>Retina UI Proofs &amp; Well-Architected SLAs</a:t>
                       </a:r>
                       <a:endParaRPr lang="en-US" sz="900" dirty="0">
                         <a:latin typeface="Google Sans" charset="0"/>
@@ -20682,7 +20682,7 @@
                 <a:ea typeface="Roboto" pitchFamily="34" charset="-122"/>
                 <a:cs typeface="Roboto" pitchFamily="34" charset="-120"/>
               </a:rPr>
-              <a:t>Workstream 1 • Reference Architecture &amp; Cloud Architecture Center Doc PR  •  Streamlined 11-Slide Executive Deck &amp; 5-Part Editorial Blog Series Roadmap</a:t>
+              <a:t>Workstream 1 • Reference Architecture &amp; Cloud Architecture Center Doc PR  •  15-Slide Executive Architecture Deck &amp; 5-Part Editorial Blog Series Roadmap</a:t>
             </a:r>
             <a:endParaRPr lang="en-US" sz="880" dirty="0"/>
           </a:p>

</xml_diff>

<commit_message>
fix(ws1): remediate Slide 2/6/12/13 audit findings and enrich CLI telemetry receipts
</commit_message>
<xml_diff>
--- a/slides/ws1-google-slides-design-plugin-editable-slides.pptx
+++ b/slides/ws1-google-slides-design-plugin-editable-slides.pptx
@@ -9733,7 +9733,7 @@
                 <a:ea typeface="Google Sans" pitchFamily="34" charset="-122"/>
                 <a:cs typeface="Google Sans" pitchFamily="34" charset="-120"/>
               </a:rPr>
-              <a:t>ACT IV • EAP PRODUCT GAP REGISTER (GAP-01..05) &amp; COMPENSATING CONTROLS</a:t>
+              <a:t>ACT III • EAP PRODUCT GAP REGISTER (GAP-01..05) &amp; COMPENSATING CONTROLS</a:t>
             </a:r>
             <a:endParaRPr lang="en-US" sz="1020" dirty="0"/>
           </a:p>
@@ -13017,7 +13017,7 @@
                 <a:ea typeface="Roboto" pitchFamily="34" charset="-122"/>
                 <a:cs typeface="Roboto" pitchFamily="34" charset="-120"/>
               </a:rPr>
-              <a:t>• Runtime: Cloud Run Gen2 (gVisor runsc, 100% traffic)</a:t>
+              <a:t>• Runtime: Cloud Run Gen2 (gVisor runsc, 100% traffic, 0 cold-start errors)</a:t>
             </a:r>
             <a:endParaRPr lang="en-US" sz="840" dirty="0"/>
           </a:p>
@@ -13034,7 +13034,41 @@
                 <a:ea typeface="Roboto" pitchFamily="34" charset="-122"/>
                 <a:cs typeface="Roboto" pitchFamily="34" charset="-120"/>
               </a:rPr>
-              <a:t>• CLI Gate: run_deep_forensic_audit.py (13/13 PASS)</a:t>
+              <a:t>• Edge &amp; STS Probe: Spoofed X-Tenant-Id -&gt; HTTP 403; Valid DPoP -&gt; HTTP 200</a:t>
+            </a:r>
+            <a:endParaRPr lang="en-US" sz="840" dirty="0"/>
+          </a:p>
+          <a:p>
+            <a:pPr indent="0" marL="0">
+              <a:buNone/>
+            </a:pPr>
+            <a:r>
+              <a:rPr lang="en-US" sz="840" dirty="0">
+                <a:solidFill>
+                  <a:srgbClr val="5F6368"/>
+                </a:solidFill>
+                <a:latin typeface="Roboto" pitchFamily="34" charset="0"/>
+                <a:ea typeface="Roboto" pitchFamily="34" charset="-122"/>
+                <a:cs typeface="Roboto" pitchFamily="34" charset="-120"/>
+              </a:rPr>
+              <a:t>• AlloyDB RLS Proof: SET LOCAL app.current_tenant_id -&gt; 0 foreign rows returned</a:t>
+            </a:r>
+            <a:endParaRPr lang="en-US" sz="840" dirty="0"/>
+          </a:p>
+          <a:p>
+            <a:pPr indent="0" marL="0">
+              <a:buNone/>
+            </a:pPr>
+            <a:r>
+              <a:rPr lang="en-US" sz="840" dirty="0">
+                <a:solidFill>
+                  <a:srgbClr val="5F6368"/>
+                </a:solidFill>
+                <a:latin typeface="Roboto" pitchFamily="34" charset="0"/>
+                <a:ea typeface="Roboto" pitchFamily="34" charset="-122"/>
+                <a:cs typeface="Roboto" pitchFamily="34" charset="-120"/>
+              </a:rPr>
+              <a:t>• CLI Gate: python3 -B scripts/run_deep_forensic_audit.py (13/13 PASS • 107/107)</a:t>
             </a:r>
             <a:endParaRPr lang="en-US" sz="840" dirty="0"/>
           </a:p>
@@ -13298,7 +13332,24 @@
                 <a:ea typeface="Roboto" pitchFamily="34" charset="-122"/>
                 <a:cs typeface="Roboto" pitchFamily="34" charset="-120"/>
               </a:rPr>
-              <a:t>• 3P UIs (2880×1800): Metabase BI v0.50.26 &amp; Trino SQL v440</a:t>
+              <a:t>• AWS AgentCore MCP: 10/10 SaaS targets READY (30/30 cross-cloud flows PASS)</a:t>
+            </a:r>
+            <a:endParaRPr lang="en-US" sz="840" dirty="0"/>
+          </a:p>
+          <a:p>
+            <a:pPr indent="0" marL="0">
+              <a:buNone/>
+            </a:pPr>
+            <a:r>
+              <a:rPr lang="en-US" sz="840" dirty="0">
+                <a:solidFill>
+                  <a:srgbClr val="5F6368"/>
+                </a:solidFill>
+                <a:latin typeface="Roboto" pitchFamily="34" charset="0"/>
+                <a:ea typeface="Roboto" pitchFamily="34" charset="-122"/>
+                <a:cs typeface="Roboto" pitchFamily="34" charset="-120"/>
+              </a:rPr>
+              <a:t>• 3P UIs (2880×1800): Metabase BI v0.50.26 &amp; Trino SQL v440 (20/20 Before/After)</a:t>
             </a:r>
             <a:endParaRPr lang="en-US" sz="840" dirty="0"/>
           </a:p>
@@ -18258,7 +18309,7 @@
                 <a:ea typeface="Roboto" pitchFamily="34" charset="-122"/>
                 <a:cs typeface="Roboto" pitchFamily="34" charset="-120"/>
               </a:rPr>
-              <a:t>Streamlined 11-slide executive deck &amp; 5-part blog series roadmap: macro-to-micro L1→L2→L3→L4 hierarchy with zero redundant slides.</a:t>
+              <a:t>15-slide executive deck &amp; 5-part blog series roadmap: Conceptual → Process → L1–L4 Technical → Dual-Plane Proofs &amp; SLAs.</a:t>
             </a:r>
             <a:endParaRPr lang="en-US" sz="980" dirty="0"/>
           </a:p>
@@ -20119,7 +20170,7 @@
               <a:buNone/>
             </a:pPr>
             <a:r>
-              <a:rPr lang="en-US" sz="760" b="1" dirty="0">
+              <a:rPr lang="en-US" sz="820" b="1" dirty="0">
                 <a:solidFill>
                   <a:srgbClr val="3C4043"/>
                 </a:solidFill>
@@ -20127,9 +20178,9 @@
                 <a:ea typeface="Google Sans" pitchFamily="34" charset="-122"/>
                 <a:cs typeface="Google Sans" pitchFamily="34" charset="-120"/>
               </a:rPr>
-              <a:t>1. Macro-to-Micro L1 → L2 → L3 → L4 Flow</a:t>
-            </a:r>
-            <a:endParaRPr lang="en-US" sz="760" dirty="0"/>
+              <a:t>1. Conceptual → Process → L1–L4 Flow</a:t>
+            </a:r>
+            <a:endParaRPr lang="en-US" sz="820" dirty="0"/>
           </a:p>
         </p:txBody>
       </p:sp>
@@ -20168,7 +20219,7 @@
                 <a:ea typeface="Roboto" pitchFamily="34" charset="-122"/>
                 <a:cs typeface="Roboto" pitchFamily="34" charset="-120"/>
               </a:rPr>
-              <a:t>Restores strict top-down abstraction: L1 Logical (Slide 5) → L2 Physical Blueprint (Slide 6) → L3 Process &amp; Breakers (Slide 7) → L4 Wire JWT (Slide 8).</a:t>
+              <a:t>Progresses from Conceptual (Slide 4) &amp; Process (Slide 5) to L1 Logical (Slide 6), L2 Blueprints (Slides 8–9), L3 UML (Slide 10) &amp; L4 Wire (Slide 11).</a:t>
             </a:r>
             <a:endParaRPr lang="en-US" sz="740" dirty="0"/>
           </a:p>
@@ -20297,7 +20348,7 @@
                 <a:ea typeface="Roboto" pitchFamily="34" charset="-122"/>
                 <a:cs typeface="Roboto" pitchFamily="34" charset="-120"/>
               </a:rPr>
-              <a:t>Separates Slide 5’s 3 Logical Security Layers (Ingress, 5-Hop Control Plane, Data Planes) from Slide 6’s 4 Physical VPC-SC Network Perimeters.</a:t>
+              <a:t>Separates Slide 6’s 3 Logical Security Layers (Ingress, 5-Hop Control Plane, Data Planes) from Slides 8–9’s 4 Physical VPC-SC Network Perimeters.</a:t>
             </a:r>
             <a:endParaRPr lang="en-US" sz="740" dirty="0"/>
           </a:p>
@@ -20385,7 +20436,7 @@
                 <a:ea typeface="Google Sans" pitchFamily="34" charset="-122"/>
                 <a:cs typeface="Google Sans" pitchFamily="34" charset="-120"/>
               </a:rPr>
-              <a:t>3. Merged L3 UML &amp; Circuit Breakers (Slide 7)</a:t>
+              <a:t>3. Merged L3 UML &amp; Circuit Breakers (Slide 10)</a:t>
             </a:r>
             <a:endParaRPr lang="en-US" sz="760" dirty="0"/>
           </a:p>
@@ -20514,7 +20565,7 @@
                 <a:ea typeface="Google Sans" pitchFamily="34" charset="-122"/>
                 <a:cs typeface="Google Sans" pitchFamily="34" charset="-120"/>
               </a:rPr>
-              <a:t>4. Merged SLAs &amp; 5-Part Roadmap (Slide 11)</a:t>
+              <a:t>4. Dual-Plane Proofs &amp; SLAs (Slides 13–15)</a:t>
             </a:r>
             <a:endParaRPr lang="en-US" sz="760" dirty="0"/>
           </a:p>
@@ -20555,7 +20606,7 @@
                 <a:ea typeface="Roboto" pitchFamily="34" charset="-122"/>
                 <a:cs typeface="Roboto" pitchFamily="34" charset="-120"/>
               </a:rPr>
-              <a:t>Consolidates all Well-Architected SLAs (~42ms 5-Hop, 84.7% token savings, 74% TCO reduction, &lt;30s RTO) directly into the 5 runnable milestones.</a:t>
+              <a:t>Pairs grounded GCP/AWS CLI telemetry (Slide 13) &amp; 2880x1800 Retina 3P SaaS UIs (Slide 14) with Well-Architected SLAs &amp; 5 milestones (Slide 15).</a:t>
             </a:r>
             <a:endParaRPr lang="en-US" sz="740" dirty="0"/>
           </a:p>
@@ -30819,7 +30870,7 @@
                 <a:ea typeface="Roboto" pitchFamily="34" charset="-122"/>
                 <a:cs typeface="Roboto" pitchFamily="34" charset="-120"/>
               </a:rPr>
-              <a:t>Workstream 1 L1 Logical Taxonomy (3 Logical Security Layers → 4 Physical VPC-SC Perimeters on Slide 6)  •  ~42ms p95 5-Hop Control Plane  •  </a:t>
+              <a:t>Workstream 1 L1 Logical Taxonomy (3 Logical Security Layers → 4 Physical VPC-SC Perimeters on Slides 8–9)  •  ~42ms p95 5-Hop Control Plane  •  </a:t>
             </a:r>
             <a:pPr algn="l" indent="0" marL="0">
               <a:buNone/>

</xml_diff>